<commit_message>
Stamp the submission commit onto slide 1 of both decks
Slide 1 pointed at f7cbe09, which predates the Ministry CA bundle, the connect
retry and the log redaction - a judge checking out that hash would get a bot that
cannot open a TLS connection to MAX at all. It now names b9f419f, the commit that
carries the whole MAX surface, with the full 40-char hash underneath so the short
form can be verified.

That value is two lines where it used to be one, which pushed the last row of the
table down against the environment card, so the two-line row pitch comes down from
0.72" to 0.68" to keep the original clearance.

Co-Authored-By: Claude Opus 5 <noreply@anthropic.com>
</commit_message>
<xml_diff>
--- a/docs/max-presentation/presentation.pptx
+++ b/docs/max-presentation/presentation.pptx
@@ -2207,7 +2207,7 @@
         </p:nvSpPr>
         <p:spPr>
           <a:xfrm>
-            <a:off x="502920" y="1371600"/>
+            <a:off x="502920" y="1316736"/>
             <a:ext cx="1691640" cy="274320"/>
           </a:xfrm>
           <a:prstGeom prst="rect">
@@ -2246,7 +2246,7 @@
         </p:nvSpPr>
         <p:spPr>
           <a:xfrm>
-            <a:off x="2240280" y="1371600"/>
+            <a:off x="2240280" y="1316736"/>
             <a:ext cx="4114800" cy="548640"/>
           </a:xfrm>
           <a:prstGeom prst="rect">
@@ -2314,7 +2314,7 @@
         </p:nvSpPr>
         <p:spPr>
           <a:xfrm>
-            <a:off x="502920" y="2029968"/>
+            <a:off x="502920" y="1938528"/>
             <a:ext cx="1691640" cy="274320"/>
           </a:xfrm>
           <a:prstGeom prst="rect">
@@ -2353,7 +2353,7 @@
         </p:nvSpPr>
         <p:spPr>
           <a:xfrm>
-            <a:off x="2240280" y="2029968"/>
+            <a:off x="2240280" y="1938528"/>
             <a:ext cx="4114800" cy="548640"/>
           </a:xfrm>
           <a:prstGeom prst="rect">
@@ -2421,7 +2421,7 @@
         </p:nvSpPr>
         <p:spPr>
           <a:xfrm>
-            <a:off x="502920" y="2688336"/>
+            <a:off x="502920" y="2560320"/>
             <a:ext cx="1691640" cy="274320"/>
           </a:xfrm>
           <a:prstGeom prst="rect">
@@ -2460,7 +2460,7 @@
         </p:nvSpPr>
         <p:spPr>
           <a:xfrm>
-            <a:off x="2240280" y="2688336"/>
+            <a:off x="2240280" y="2560320"/>
             <a:ext cx="4114800" cy="548640"/>
           </a:xfrm>
           <a:prstGeom prst="rect">
@@ -2502,7 +2502,7 @@
         </p:nvSpPr>
         <p:spPr>
           <a:xfrm>
-            <a:off x="502920" y="3145536"/>
+            <a:off x="502920" y="3017520"/>
             <a:ext cx="1691640" cy="274320"/>
           </a:xfrm>
           <a:prstGeom prst="rect">
@@ -2541,7 +2541,7 @@
         </p:nvSpPr>
         <p:spPr>
           <a:xfrm>
-            <a:off x="2240280" y="3145536"/>
+            <a:off x="2240280" y="3017520"/>
             <a:ext cx="4114800" cy="548640"/>
           </a:xfrm>
           <a:prstGeom prst="rect">
@@ -2569,10 +2569,36 @@
                 <a:ea typeface="Calibri" pitchFamily="34" charset="-122"/>
                 <a:cs typeface="Calibri" pitchFamily="34" charset="-120"/>
               </a:rPr>
-              <a:t>ЗАПОЛНИТЬ ПЕРЕД СДАЧЕЙ · ветка main</a:t>
-            </a:r>
+              <a:t>b9f419f · ветка main</a:t>
+            </a:r>
+            <a:pPr indent="0" marL="0">
+              <a:lnSpc>
+                <a:spcPct val="105000"/>
+              </a:lnSpc>
+              <a:buNone/>
+            </a:pPr>
             <a:endParaRPr lang="en-US" sz="1200" dirty="0"/>
           </a:p>
+          <a:p>
+            <a:pPr indent="0" marL="0">
+              <a:lnSpc>
+                <a:spcPct val="105000"/>
+              </a:lnSpc>
+              <a:buNone/>
+            </a:pPr>
+            <a:r>
+              <a:rPr lang="en-US" sz="1050" dirty="0">
+                <a:solidFill>
+                  <a:srgbClr val="79839A"/>
+                </a:solidFill>
+                <a:latin typeface="Calibri" pitchFamily="34" charset="0"/>
+                <a:ea typeface="Calibri" pitchFamily="34" charset="-122"/>
+                <a:cs typeface="Calibri" pitchFamily="34" charset="-120"/>
+              </a:rPr>
+              <a:t>b9f419fbe69b0e707b6dfc1a7dbd0cfd6370f6e6</a:t>
+            </a:r>
+            <a:endParaRPr lang="en-US" sz="1200" dirty="0"/>
+          </a:p>
         </p:txBody>
       </p:sp>
       <p:sp>
@@ -2583,7 +2609,7 @@
         </p:nvSpPr>
         <p:spPr>
           <a:xfrm>
-            <a:off x="502920" y="3602736"/>
+            <a:off x="502920" y="3639312"/>
             <a:ext cx="1691640" cy="274320"/>
           </a:xfrm>
           <a:prstGeom prst="rect">
@@ -2622,7 +2648,7 @@
         </p:nvSpPr>
         <p:spPr>
           <a:xfrm>
-            <a:off x="2240280" y="3602736"/>
+            <a:off x="2240280" y="3639312"/>
             <a:ext cx="4114800" cy="548640"/>
           </a:xfrm>
           <a:prstGeom prst="rect">

</xml_diff>

<commit_message>
Point slide 1 at the commit that actually works
b9f419f predates the open_app button fix, so a judge checking it out would get a
deck describing a storefront button that MAX rejects. 967024c is the first commit
where the whole path - message in, storefront out, button opens the mini app - runs
against the live platform.

Co-Authored-By: Claude Opus 5 <noreply@anthropic.com>
</commit_message>
<xml_diff>
--- a/docs/max-presentation/presentation.pptx
+++ b/docs/max-presentation/presentation.pptx
@@ -2569,7 +2569,7 @@
                 <a:ea typeface="Calibri" pitchFamily="34" charset="-122"/>
                 <a:cs typeface="Calibri" pitchFamily="34" charset="-120"/>
               </a:rPr>
-              <a:t>b9f419f · ветка main</a:t>
+              <a:t>967024c · ветка main</a:t>
             </a:r>
             <a:pPr indent="0" marL="0">
               <a:lnSpc>
@@ -2595,7 +2595,7 @@
                 <a:ea typeface="Calibri" pitchFamily="34" charset="-122"/>
                 <a:cs typeface="Calibri" pitchFamily="34" charset="-120"/>
               </a:rPr>
-              <a:t>b9f419fbe69b0e707b6dfc1a7dbd0cfd6370f6e6</a:t>
+              <a:t>967024c0cb024ab93c623fc4e6189b29a17cfede</a:t>
             </a:r>
             <a:endParaRPr lang="en-US" sz="1200" dirty="0"/>
           </a:p>

</xml_diff>

<commit_message>
Point slide 1 at the commit with the mini-app flow
967024c is the chat wizard: a judge following the new verification steps on it would
describe their business to a bot that no longer builds anything. 376b483 is the first
commit where slide 1's path - start the bot, open the app, describe, share, book,
confirm - is what the product does.

Co-Authored-By: Claude Opus 5 <noreply@anthropic.com>
</commit_message>
<xml_diff>
--- a/docs/max-presentation/presentation.pptx
+++ b/docs/max-presentation/presentation.pptx
@@ -2658,7 +2658,7 @@
                 <a:ea typeface="Calibri" pitchFamily="34" charset="-122"/>
                 <a:cs typeface="Calibri" pitchFamily="34" charset="-120"/>
               </a:rPr>
-              <a:t>967024c · ветка main</a:t>
+              <a:t>376b483 · ветка main</a:t>
             </a:r>
             <a:pPr indent="0" marL="0">
               <a:lnSpc>
@@ -2684,7 +2684,7 @@
                 <a:ea typeface="Calibri" pitchFamily="34" charset="-122"/>
                 <a:cs typeface="Calibri" pitchFamily="34" charset="-120"/>
               </a:rPr>
-              <a:t>967024c0cb024ab93c623fc4e6189b29a17cfede</a:t>
+              <a:t>376b483180331187bd900c2dce8a18bda4ca5672</a:t>
             </a:r>
             <a:endParaRPr lang="en-US" sz="1200" dirty="0"/>
           </a:p>

</xml_diff>

<commit_message>
Mark MAX bot dialogs as read and rebrand the mini-app as AIRuntime.
Co-authored-by: Cursor <cursoragent@cursor.com>
</commit_message>
<xml_diff>
--- a/docs/max-presentation/presentation.pptx
+++ b/docs/max-presentation/presentation.pptx
@@ -3018,7 +3018,7 @@
                 <a:ea typeface="Calibri" pitchFamily="34" charset="-122"/>
                 <a:cs typeface="Calibri" pitchFamily="34" charset="-120"/>
               </a:rPr>
-              <a:t>Подключено к боту: кнопка «Открыть Витрину» и ссылки max.ru/t403_hakaton_max_bot?startapp=&lt;slug&gt;</a:t>
+              <a:t>Подключено к боту: кнопка «Открыть AIRuntime» и ссылки max.ru/t403_hakaton_max_bot?startapp=&lt;slug&gt;</a:t>
             </a:r>
             <a:endParaRPr lang="en-US" sz="1150" dirty="0"/>
           </a:p>
@@ -3665,7 +3665,7 @@
                 <a:ea typeface="Calibri" pitchFamily="34" charset="-122"/>
                 <a:cs typeface="Calibri" pitchFamily="34" charset="-120"/>
               </a:rPr>
-              <a:t> = по запросу; без ключа витрина собирается шаблоном</a:t>
+              <a:t> = по запросу; без ключа сервис собирается шаблоном</a:t>
             </a:r>
             <a:endParaRPr lang="en-US" sz="1050" dirty="0"/>
           </a:p>
@@ -3826,7 +3826,7 @@
                 <a:ea typeface="Calibri" pitchFamily="34" charset="-122"/>
                 <a:cs typeface="Calibri" pitchFamily="34" charset="-120"/>
               </a:rPr>
-              <a:t>Открыть max.ru/t403_hakaton_max_bot, нажать «Начать», затем «Открыть Витрину»</a:t>
+              <a:t>Открыть max.ru/t403_hakaton_max_bot, нажать «Начать», затем «Открыть AIRuntime»</a:t>
             </a:r>
             <a:endParaRPr lang="en-US" sz="1250" dirty="0"/>
           </a:p>
@@ -3872,7 +3872,7 @@
                 <a:ea typeface="Calibri" pitchFamily="34" charset="-122"/>
                 <a:cs typeface="Calibri" pitchFamily="34" charset="-120"/>
               </a:rPr>
-              <a:t>: «Автосервис на Лесной. Диагностика 1500, замена масла 900, шиномонтаж 2400. Работаем с 9 до 20» — и нажать «Собрать витрину»</a:t>
+              <a:t>: «Автосервис на Лесной. Диагностика 1500, замена масла 900, шиномонтаж 2400. Работаем с 9 до 20» — и нажать «Собрать AIRuntime»</a:t>
             </a:r>
             <a:endParaRPr lang="en-US" sz="1250" dirty="0"/>
           </a:p>
@@ -3896,7 +3896,7 @@
                 <a:ea typeface="Calibri" pitchFamily="34" charset="-122"/>
                 <a:cs typeface="Calibri" pitchFamily="34" charset="-120"/>
               </a:rPr>
-              <a:t>Через ~10 секунд витрина опубликована: ссылка, «Поделиться», «Посмотреть»</a:t>
+              <a:t>Через ~10 секунд сервис опубликован: ссылка, «Поделиться», «Посмотреть»</a:t>
             </a:r>
             <a:endParaRPr lang="en-US" sz="1250" dirty="0"/>
           </a:p>
@@ -4839,7 +4839,7 @@
                 <a:ea typeface="Calibri" pitchFamily="34" charset="-122"/>
                 <a:cs typeface="Calibri" pitchFamily="34" charset="-120"/>
               </a:rPr>
-              <a:t>Открыть витрину</a:t>
+              <a:t>Открыть AIRuntime</a:t>
             </a:r>
             <a:endParaRPr lang="en-US" sz="1150" dirty="0"/>
           </a:p>
@@ -5055,7 +5055,7 @@
                 <a:ea typeface="Calibri" pitchFamily="34" charset="-122"/>
                 <a:cs typeface="Calibri" pitchFamily="34" charset="-120"/>
               </a:rPr>
-              <a:t>Скелетоны экрана и индикатор сборки витрины</a:t>
+              <a:t>Скелетоны экрана и индикатор сборки AIRuntime</a:t>
             </a:r>
             <a:endParaRPr lang="en-US" sz="1250" dirty="0"/>
           </a:p>
@@ -5117,7 +5117,7 @@
                 <a:ea typeface="Calibri" pitchFamily="34" charset="-122"/>
                 <a:cs typeface="Calibri" pitchFamily="34" charset="-120"/>
               </a:rPr>
-              <a:t>«Витрина готова», «Заявка принята», статусы заявок</a:t>
+              <a:t>«AIRuntime готов», «Заявка принята», статусы заявок</a:t>
             </a:r>
             <a:endParaRPr lang="en-US" sz="1250" dirty="0"/>
           </a:p>
@@ -5623,7 +5623,7 @@
                 <a:ea typeface="Calibri" pitchFamily="34" charset="-122"/>
                 <a:cs typeface="Calibri" pitchFamily="34" charset="-120"/>
               </a:rPr>
-              <a:t> — открыл витрину → отправил заявку</a:t>
+              <a:t> — открыл AIRuntime → отправил заявку</a:t>
             </a:r>
             <a:endParaRPr lang="en-US" sz="1250" dirty="0"/>
           </a:p>
@@ -5967,7 +5967,7 @@
                 <a:ea typeface="Calibri" pitchFamily="34" charset="-122"/>
                 <a:cs typeface="Calibri" pitchFamily="34" charset="-120"/>
               </a:rPr>
-              <a:t>Пилот — три недели через витрину, сравнение по тем же величинам</a:t>
+              <a:t>Пилот — три недели через AIRuntime, сравнение по тем же величинам</a:t>
             </a:r>
             <a:endParaRPr lang="en-US" sz="1250" dirty="0"/>
           </a:p>
@@ -6508,7 +6508,7 @@
                 <a:ea typeface="Calibri" pitchFamily="34" charset="-122"/>
                 <a:cs typeface="Calibri" pitchFamily="34" charset="-120"/>
               </a:rPr>
-              <a:t>Описание → опубликованная витрина</a:t>
+              <a:t>Описание → опубликованный сервис</a:t>
             </a:r>
             <a:endParaRPr lang="en-US" sz="1200" dirty="0"/>
           </a:p>
@@ -6765,7 +6765,7 @@
                 <a:ea typeface="Calibri" pitchFamily="34" charset="-122"/>
                 <a:cs typeface="Calibri" pitchFamily="34" charset="-120"/>
               </a:rPr>
-              <a:t>Правка витрины одной фразой</a:t>
+              <a:t>Правка одной фразой</a:t>
             </a:r>
             <a:endParaRPr lang="en-US" sz="1200" dirty="0"/>
           </a:p>
@@ -7279,7 +7279,7 @@
                 <a:ea typeface="Calibri" pitchFamily="34" charset="-122"/>
                 <a:cs typeface="Calibri" pitchFamily="34" charset="-120"/>
               </a:rPr>
-              <a:t>Онлайн-оплата: витрина доводит до заявки</a:t>
+              <a:t>Онлайн-оплата: сервис доводит до заявки</a:t>
             </a:r>
             <a:endParaRPr lang="en-US" sz="1200" dirty="0"/>
           </a:p>
@@ -7351,7 +7351,7 @@
                 <a:ea typeface="Calibri" pitchFamily="34" charset="-122"/>
                 <a:cs typeface="Calibri" pitchFamily="34" charset="-120"/>
               </a:rPr>
-              <a:t>Код под каждый бизнес: витрина — это данные</a:t>
+              <a:t>Код под каждый бизнес: AIRuntime — это данные</a:t>
             </a:r>
             <a:endParaRPr lang="en-US" sz="1200" dirty="0"/>
           </a:p>
@@ -7982,7 +7982,7 @@
                 <a:ea typeface="Calibri" pitchFamily="34" charset="-122"/>
                 <a:cs typeface="Calibri" pitchFamily="34" charset="-120"/>
               </a:rPr>
-              <a:t>создание, витрина, заявки</a:t>
+              <a:t>создание, сервис, заявки</a:t>
             </a:r>
             <a:endParaRPr lang="en-US" sz="1050" dirty="0"/>
           </a:p>
@@ -8258,7 +8258,7 @@
                 <a:ea typeface="Calibri" pitchFamily="34" charset="-122"/>
                 <a:cs typeface="Calibri" pitchFamily="34" charset="-120"/>
               </a:rPr>
-              <a:t>Генератор витрины</a:t>
+              <a:t>Генератор сервиса</a:t>
             </a:r>
             <a:endParaRPr lang="en-US" sz="1350" dirty="0"/>
           </a:p>
@@ -8402,7 +8402,7 @@
                 <a:ea typeface="Calibri" pitchFamily="34" charset="-122"/>
                 <a:cs typeface="Calibri" pitchFamily="34" charset="-120"/>
               </a:rPr>
-              <a:t>владельцы, витрины, заявки</a:t>
+              <a:t>владельцы, сервисы, заявки</a:t>
             </a:r>
             <a:endParaRPr lang="en-US" sz="1050" dirty="0"/>
           </a:p>
@@ -8910,7 +8910,7 @@
                 <a:ea typeface="Calibri" pitchFamily="34" charset="-122"/>
                 <a:cs typeface="Calibri" pitchFamily="34" charset="-120"/>
               </a:rPr>
-              <a:t>Витрина — это данные, а не код</a:t>
+              <a:t>AIRuntime — это данные, а не код</a:t>
             </a:r>
             <a:endParaRPr lang="en-US" sz="1350" dirty="0"/>
           </a:p>
@@ -8950,7 +8950,7 @@
                 <a:ea typeface="Calibri" pitchFamily="34" charset="-122"/>
                 <a:cs typeface="Calibri" pitchFamily="34" charset="-120"/>
               </a:rPr>
-              <a:t>Модель заполняет схему, а не пишет программу: один мультитенантный мини-апп рендерит все витрины. «Описал → клиент может записаться» занимает секунды, а кривое поле обрезает валидация.</a:t>
+              <a:t>Модель заполняет схему, а не пишет программу: один мультитенантный мини-апп рендерит все сервисы. «Описал → клиент может записаться» занимает секунды, а кривое поле обрезает валидация.</a:t>
             </a:r>
             <a:endParaRPr lang="en-US" sz="1350" dirty="0"/>
           </a:p>
@@ -9066,7 +9066,7 @@
                 <a:ea typeface="Calibri" pitchFamily="34" charset="-122"/>
                 <a:cs typeface="Calibri" pitchFamily="34" charset="-120"/>
               </a:rPr>
-              <a:t>Как советует задание: чат-бот — для уведомлений и коротких действий, форма, каталог и список заявок — в мини-приложении. Первая версия с мастером в чате делала витрину из любого сообщения, мы её заменили.</a:t>
+              <a:t>Как советует задание: чат-бот — для уведомлений и коротких действий, форма, каталог и список заявок — в мини-приложении. Первая версия с мастером в чате делала сервис из любого сообщения, мы её заменили.</a:t>
             </a:r>
             <a:endParaRPr lang="en-US" sz="1350" dirty="0"/>
           </a:p>
@@ -9182,7 +9182,7 @@
                 <a:ea typeface="Calibri" pitchFamily="34" charset="-122"/>
                 <a:cs typeface="Calibri" pitchFamily="34" charset="-120"/>
               </a:rPr>
-              <a:t>Мини-приложение подключено к чат-боту и не живёт отдельно. Роль задаёт стартовый параметр: без него — кабинет владельца, со слагом витрины — витрина для клиента.</a:t>
+              <a:t>Мини-приложение подключено к чат-боту и не живёт отдельно. Роль задаёт стартовый параметр: без него — кабинет владельца, со слагом сервиса — страница для клиента.</a:t>
             </a:r>
             <a:endParaRPr lang="en-US" sz="1350" dirty="0"/>
           </a:p>
@@ -9607,7 +9607,7 @@
                 <a:ea typeface="Calibri" pitchFamily="34" charset="-122"/>
                 <a:cs typeface="Calibri" pitchFamily="34" charset="-120"/>
               </a:rPr>
-              <a:t>Повторный прогон сценария — новая витрина со своим адресом; после 10 — понятное сообщение, лишние удаляются кнопкой</a:t>
+              <a:t>Повторный прогон сценария — новый сервис со своим адресом; после 10 — понятное сообщение, лишние удаляются кнопкой</a:t>
             </a:r>
             <a:endParaRPr lang="en-US" sz="1150" dirty="0"/>
           </a:p>
@@ -9774,7 +9774,7 @@
                 <a:ea typeface="Calibri" pitchFamily="34" charset="-122"/>
                 <a:cs typeface="Calibri" pitchFamily="34" charset="-120"/>
               </a:rPr>
-              <a:t>Владелец видит и меняет только свои витрины и заявки</a:t>
+              <a:t>Владелец видит и меняет только свои сервисы и заявки</a:t>
             </a:r>
             <a:endParaRPr lang="en-US" sz="1150" dirty="0"/>
           </a:p>
@@ -10013,7 +10013,7 @@
                 <a:ea typeface="Calibri" pitchFamily="34" charset="-122"/>
                 <a:cs typeface="Calibri" pitchFamily="34" charset="-120"/>
               </a:rPr>
-              <a:t>54 автотеста: подделка подписи, чужой токен, чужие витрины, сквозной сценарий через HTTP</a:t>
+              <a:t>54 автотеста: подделка подписи, чужой токен, чужие сервисы, сквозной сценарий через HTTP</a:t>
             </a:r>
             <a:endParaRPr lang="en-US" sz="1150" dirty="0"/>
           </a:p>
@@ -10100,7 +10100,7 @@
                 <a:ea typeface="Calibri" pitchFamily="34" charset="-122"/>
                 <a:cs typeface="Calibri" pitchFamily="34" charset="-120"/>
               </a:rPr>
-              <a:t> витрина из описания собирается за ~9 секунд с реальной моделью, правка — за ~3 секунды; сообщения бота с баннером и кнопками проходят валидацию MAX API.</a:t>
+              <a:t> сервис из описания собирается за ~9 секунд с реальной моделью, правка — за ~3 секунды; сообщения бота с баннером и кнопками проходят валидацию MAX API.</a:t>
             </a:r>
             <a:endParaRPr lang="en-US" sz="1250" dirty="0"/>
           </a:p>
@@ -10730,7 +10730,7 @@
                 <a:ea typeface="Calibri" pitchFamily="34" charset="-122"/>
                 <a:cs typeface="Calibri" pitchFamily="34" charset="-120"/>
               </a:rPr>
-              <a:t>Каждое сообщение бота открывает нужный экран: владельцу — заявки, клиенту — его витрину. Диплинк startapp — для ссылки и QR-кода.</a:t>
+              <a:t>Каждое сообщение бота открывает нужный экран: владельцу — заявки, клиенту — его сервис. Диплинк startapp — для ссылки и QR-кода.</a:t>
             </a:r>
             <a:endParaRPr lang="en-US" sz="1150" dirty="0"/>
           </a:p>
@@ -10982,7 +10982,7 @@
                 <a:ea typeface="Calibri" pitchFamily="34" charset="-122"/>
                 <a:cs typeface="Calibri" pitchFamily="34" charset="-120"/>
               </a:rPr>
-              <a:t>Родная кнопка «Назад» в предпросмотре витрины; если закрыть приложение во время сборки, MAX переспросит.</a:t>
+              <a:t>Родная кнопка «Назад» в предпросмотре; если закрыть приложение во время сборки, MAX переспросит.</a:t>
             </a:r>
             <a:endParaRPr lang="en-US" sz="1150" dirty="0"/>
           </a:p>
@@ -11629,7 +11629,7 @@
                 <a:ea typeface="Calibri" pitchFamily="34" charset="-122"/>
                 <a:cs typeface="Calibri" pitchFamily="34" charset="-120"/>
               </a:rPr>
-              <a:t> — то, что клиент выбрал в витрине</a:t>
+              <a:t> — то, что клиент выбрал в сервисе</a:t>
             </a:r>
             <a:endParaRPr lang="en-US" sz="1200" dirty="0"/>
           </a:p>
@@ -11796,7 +11796,7 @@
                 <a:ea typeface="Calibri" pitchFamily="34" charset="-122"/>
                 <a:cs typeface="Calibri" pitchFamily="34" charset="-120"/>
               </a:rPr>
-              <a:t>Модель недоступна — витрина собирается шаблоном, сценарий не блокируется</a:t>
+              <a:t>Модель недоступна — сервис собирается шаблоном, сценарий не блокируется</a:t>
             </a:r>
             <a:endParaRPr lang="en-US" sz="1200" dirty="0"/>
           </a:p>
@@ -11996,7 +11996,7 @@
                 <a:ea typeface="Calibri" pitchFamily="34" charset="-122"/>
                 <a:cs typeface="Calibri" pitchFamily="34" charset="-120"/>
               </a:rPr>
-              <a:t> — описание → конфигурация витрины, с детерминированным фоллбэком</a:t>
+              <a:t> — описание → конфигурация сервиса, с детерминированным фоллбэком</a:t>
             </a:r>
             <a:endParaRPr lang="en-US" sz="1200" dirty="0"/>
           </a:p>
@@ -12147,7 +12147,7 @@
                 <a:ea typeface="Calibri" pitchFamily="34" charset="-122"/>
                 <a:cs typeface="Calibri" pitchFamily="34" charset="-120"/>
               </a:rPr>
-              <a:t>«Автосервис на Лесной» и заявки на слайдах 8–10 — демо: не реальные организации и клиенты. Витрины созданы через тот же продуктовый сценарий, а экраны сняты с подставленными демо-данными.</a:t>
+              <a:t>«Автосервис на Лесной» и заявки на слайдах 8–10 — демо: не реальные организации и клиенты. Сервисы созданы через тот же продуктовый сценарий, а экраны сняты с подставленными демо-данными.</a:t>
             </a:r>
             <a:endParaRPr lang="en-US" sz="1450" dirty="0"/>
           </a:p>
@@ -12549,7 +12549,7 @@
                 <a:ea typeface="Calibri" pitchFamily="34" charset="-122"/>
                 <a:cs typeface="Calibri" pitchFamily="34" charset="-120"/>
               </a:rPr>
-              <a:t>Схема витрины: позиции, цены, длительность, время, поля заявки</a:t>
+              <a:t>Схема сервиса: позиции, цены, длительность, время, поля заявки</a:t>
             </a:r>
             <a:endParaRPr lang="en-US" sz="1200" dirty="0"/>
           </a:p>
@@ -12621,7 +12621,7 @@
                 <a:ea typeface="Calibri" pitchFamily="34" charset="-122"/>
                 <a:cs typeface="Calibri" pitchFamily="34" charset="-120"/>
               </a:rPr>
-              <a:t>Мультитенантный рендер: новая витрина не требует деплоя</a:t>
+              <a:t>Мультитенантный рендер: новый сервис не требует деплоя</a:t>
             </a:r>
             <a:endParaRPr lang="en-US" sz="1200" dirty="0"/>
           </a:p>
@@ -12740,7 +12740,7 @@
                 <a:ea typeface="Calibri" pitchFamily="34" charset="-122"/>
                 <a:cs typeface="Calibri" pitchFamily="34" charset="-120"/>
               </a:rPr>
-              <a:t>Тип витрины: запись / меню / заявка — </a:t>
+              <a:t>Тип сервиса: запись / меню / заявка — </a:t>
             </a:r>
             <a:r>
               <a:rPr lang="en-US" sz="1200" b="1" dirty="0">
@@ -12934,7 +12934,7 @@
                 <a:ea typeface="Calibri" pitchFamily="34" charset="-122"/>
                 <a:cs typeface="Calibri" pitchFamily="34" charset="-120"/>
               </a:rPr>
-              <a:t> кафе и пекарни (предзаказ), аренда инвентаря и помещений, секции и студии (запись на занятия), ремонт и бытовые услуги (вызов мастера). Каждое направление использует готовый тип витрины и меняет только переменную часть. Порядок — на следующем слайде.</a:t>
+              <a:t> кафе и пекарни (предзаказ), аренда инвентаря и помещений, секции и студии (запись на занятия), ремонт и бытовые услуги (вызов мастера). Каждое направление использует готовый тип сервиса и меняет только переменную часть. Порядок — на следующем слайде.</a:t>
             </a:r>
             <a:endParaRPr lang="en-US" sz="1250" dirty="0"/>
           </a:p>
@@ -13144,7 +13144,7 @@
                 <a:ea typeface="Calibri" pitchFamily="34" charset="-122"/>
                 <a:cs typeface="Calibri" pitchFamily="34" charset="-120"/>
               </a:rPr>
-              <a:t>Как Витрина переходит из пилота дальше</a:t>
+              <a:t>Как AIRuntime переходит из пилота дальше</a:t>
             </a:r>
             <a:endParaRPr lang="en-US" sz="3200" dirty="0"/>
           </a:p>
@@ -14131,7 +14131,7 @@
                 <a:ea typeface="Calibri" pitchFamily="34" charset="-122"/>
                 <a:cs typeface="Calibri" pitchFamily="34" charset="-120"/>
               </a:rPr>
-              <a:t>роли «сеть → филиал → мастер», витрина на филиал — первая доработка ядра</a:t>
+              <a:t>роли «сеть → филиал → мастер», сервис на филиал — первая доработка ядра</a:t>
             </a:r>
             <a:endParaRPr lang="en-US" sz="850" dirty="0"/>
           </a:p>
@@ -14260,7 +14260,7 @@
                 <a:ea typeface="Calibri" pitchFamily="34" charset="-122"/>
                 <a:cs typeface="Calibri" pitchFamily="34" charset="-120"/>
               </a:rPr>
-              <a:t>сеть переводит на витрины все свои точки</a:t>
+              <a:t>сеть переводит на AIRuntime все свои точки</a:t>
             </a:r>
             <a:endParaRPr lang="en-US" sz="850" dirty="0"/>
           </a:p>
@@ -14503,7 +14503,7 @@
                 <a:ea typeface="Calibri" pitchFamily="34" charset="-122"/>
                 <a:cs typeface="Calibri" pitchFamily="34" charset="-120"/>
               </a:rPr>
-              <a:t>правила времени и праздники региона; модерация витрин</a:t>
+              <a:t>правила времени и праздники региона; модерация сервисов</a:t>
             </a:r>
             <a:endParaRPr lang="en-US" sz="850" dirty="0"/>
           </a:p>
@@ -14632,7 +14632,7 @@
                 <a:ea typeface="Calibri" pitchFamily="34" charset="-122"/>
                 <a:cs typeface="Calibri" pitchFamily="34" charset="-120"/>
               </a:rPr>
-              <a:t>консультант собирает витрину вместе с предпринимателем на приёме</a:t>
+              <a:t>консультант собирает сервис вместе с предпринимателем на приёме</a:t>
             </a:r>
             <a:endParaRPr lang="en-US" sz="850" dirty="0"/>
           </a:p>
@@ -14719,7 +14719,7 @@
                 <a:ea typeface="Calibri" pitchFamily="34" charset="-122"/>
                 <a:cs typeface="Calibri" pitchFamily="34" charset="-120"/>
               </a:rPr>
-              <a:t> та же механика «одно сообщение → работающий сервис в MAX» подходит не только бизнесу — продуктовые команды проверяют гипотезы без разработки, люди делают небольшие сервисы для себя. Это ядро AIRuntime; Витрина — первый вертикальный сценарий на нём.</a:t>
+              <a:t> та же механика «одно сообщение → работающий сервис в MAX» подходит не только бизнесу — продуктовые команды проверяют гипотезы без разработки, люди делают небольшие сервисы для себя. Это ядро AIRuntime: первый вертикальный сценарий на этой механике.</a:t>
             </a:r>
             <a:endParaRPr lang="en-US" sz="1150" dirty="0"/>
           </a:p>
@@ -15277,7 +15277,7 @@
                 <a:ea typeface="Calibri" pitchFamily="34" charset="-122"/>
                 <a:cs typeface="Calibri" pitchFamily="34" charset="-120"/>
               </a:rPr>
-              <a:t>Витрина заменяет пересказ прайса и согласование времени. Приём, оплата и сама услуга остаются как были.</a:t>
+              <a:t>AIRuntime заменяет пересказ прайса и согласование времени. Приём, оплата и сама услуга остаются как были.</a:t>
             </a:r>
             <a:endParaRPr lang="en-US" sz="1450" dirty="0"/>
           </a:p>
@@ -15393,7 +15393,7 @@
                 <a:ea typeface="Calibri" pitchFamily="34" charset="-122"/>
                 <a:cs typeface="Calibri" pitchFamily="34" charset="-120"/>
               </a:rPr>
-              <a:t>Владелец создаёт витрину и подтверждает записи, клиенты записываются, команда сопровождает и снимает метрики. Внешние владельцы процесса не нужны.</a:t>
+              <a:t>Владелец создаёт сервис и подтверждает записи, клиенты записываются, команда сопровождает и снимает метрики. Внешние владельцы процесса не нужны.</a:t>
             </a:r>
             <a:endParaRPr lang="en-US" sz="1450" dirty="0"/>
           </a:p>
@@ -15981,501 +15981,9 @@
           </a:p>
         </p:txBody>
       </p:sp>
-      <p:sp>
-        <p:nvSpPr>
-          <p:cNvPr id="5" name="Shape 2"/>
-          <p:cNvSpPr/>
-          <p:nvPr/>
-        </p:nvSpPr>
-        <p:spPr>
-          <a:xfrm>
-            <a:off x="2371725" y="1376363"/>
-            <a:ext cx="219075" cy="219075"/>
-          </a:xfrm>
-          <a:prstGeom prst="ellipse">
-            <a:avLst/>
-          </a:prstGeom>
-          <a:solidFill>
-            <a:srgbClr val="FFFFFF"/>
-          </a:solidFill>
-          <a:ln w="12700">
-            <a:solidFill>
-              <a:srgbClr val="FFFFFF"/>
-            </a:solidFill>
-            <a:prstDash val="solid"/>
-          </a:ln>
-        </p:spPr>
-      </p:sp>
-      <p:sp>
-        <p:nvSpPr>
-          <p:cNvPr id="6" name="Shape 3"/>
-          <p:cNvSpPr/>
-          <p:nvPr/>
-        </p:nvSpPr>
-        <p:spPr>
-          <a:xfrm>
-            <a:off x="2443163" y="1447800"/>
-            <a:ext cx="76200" cy="76200"/>
-          </a:xfrm>
-          <a:prstGeom prst="ellipse">
-            <a:avLst/>
-          </a:prstGeom>
-          <a:solidFill>
-            <a:srgbClr val="0077FF"/>
-          </a:solidFill>
-          <a:ln w="12700">
-            <a:solidFill>
-              <a:srgbClr val="0077FF"/>
-            </a:solidFill>
-            <a:prstDash val="solid"/>
-          </a:ln>
-        </p:spPr>
-      </p:sp>
-      <p:sp>
-        <p:nvSpPr>
-          <p:cNvPr id="7" name="Text 4"/>
-          <p:cNvSpPr txBox="1"/>
-          <p:nvPr/>
-        </p:nvSpPr>
-        <p:spPr>
-          <a:xfrm>
-            <a:off x="2667000" y="1333500"/>
-            <a:ext cx="762000" cy="304800"/>
-          </a:xfrm>
-          <a:prstGeom prst="rect">
-            <a:avLst/>
-          </a:prstGeom>
-          <a:noFill/>
-          <a:ln/>
-        </p:spPr>
-        <p:txBody>
-          <a:bodyPr wrap="square" lIns="0" tIns="0" rIns="0" bIns="0" rtlCol="0" anchor="ctr"/>
-          <a:lstStyle/>
-          <a:p>
-            <a:pPr indent="0" marL="0">
-              <a:buNone/>
-            </a:pPr>
-            <a:r>
-              <a:rPr lang="en-US" sz="1600" b="1" dirty="0">
-                <a:solidFill>
-                  <a:srgbClr val="FFFFFF"/>
-                </a:solidFill>
-                <a:latin typeface="Calibri" pitchFamily="34" charset="0"/>
-                <a:ea typeface="Calibri" pitchFamily="34" charset="-122"/>
-                <a:cs typeface="Calibri" pitchFamily="34" charset="-120"/>
-              </a:rPr>
-              <a:t>max</a:t>
-            </a:r>
-            <a:endParaRPr lang="en-US" sz="1600" dirty="0"/>
-          </a:p>
-        </p:txBody>
-      </p:sp>
-      <p:sp>
-        <p:nvSpPr>
-          <p:cNvPr id="8" name="Text 5"/>
-          <p:cNvSpPr txBox="1"/>
-          <p:nvPr/>
-        </p:nvSpPr>
-        <p:spPr>
-          <a:xfrm>
-            <a:off x="685800" y="1943100"/>
-            <a:ext cx="4953000" cy="190500"/>
-          </a:xfrm>
-          <a:prstGeom prst="rect">
-            <a:avLst/>
-          </a:prstGeom>
-          <a:noFill/>
-          <a:ln/>
-        </p:spPr>
-        <p:txBody>
-          <a:bodyPr wrap="square" lIns="0" tIns="0" rIns="0" bIns="0" rtlCol="0" anchor="ctr"/>
-          <a:lstStyle/>
-          <a:p>
-            <a:pPr indent="0" marL="0">
-              <a:buNone/>
-            </a:pPr>
-            <a:r>
-              <a:rPr lang="en-US" sz="860" b="1" spc="200" kern="0" dirty="0">
-                <a:solidFill>
-                  <a:srgbClr val="8EC4FF"/>
-                </a:solidFill>
-                <a:latin typeface="Calibri" pitchFamily="34" charset="0"/>
-                <a:ea typeface="Calibri" pitchFamily="34" charset="-122"/>
-                <a:cs typeface="Calibri" pitchFamily="34" charset="-120"/>
-              </a:rPr>
-              <a:t>ТРЕК «ЭФФЕКТИВНЫЙ БИЗНЕС»</a:t>
-            </a:r>
-            <a:endParaRPr lang="en-US" sz="860" dirty="0"/>
-          </a:p>
-        </p:txBody>
-      </p:sp>
-      <p:sp>
-        <p:nvSpPr>
-          <p:cNvPr id="9" name="Text 6"/>
-          <p:cNvSpPr txBox="1"/>
-          <p:nvPr/>
-        </p:nvSpPr>
-        <p:spPr>
-          <a:xfrm>
-            <a:off x="647700" y="2152650"/>
-            <a:ext cx="5334000" cy="1181100"/>
-          </a:xfrm>
-          <a:prstGeom prst="rect">
-            <a:avLst/>
-          </a:prstGeom>
-          <a:noFill/>
-          <a:ln/>
-        </p:spPr>
-        <p:txBody>
-          <a:bodyPr wrap="square" lIns="0" tIns="0" rIns="0" bIns="0" rtlCol="0" anchor="t"/>
-          <a:lstStyle/>
-          <a:p>
-            <a:pPr indent="0" marL="0">
-              <a:buNone/>
-            </a:pPr>
-            <a:r>
-              <a:rPr lang="en-US" sz="8400" b="1" dirty="0">
-                <a:solidFill>
-                  <a:srgbClr val="FFFFFF"/>
-                </a:solidFill>
-                <a:latin typeface="Calibri" pitchFamily="34" charset="0"/>
-                <a:ea typeface="Calibri" pitchFamily="34" charset="-122"/>
-                <a:cs typeface="Calibri" pitchFamily="34" charset="-120"/>
-              </a:rPr>
-              <a:t>Витрина</a:t>
-            </a:r>
-            <a:endParaRPr lang="en-US" sz="8400" dirty="0"/>
-          </a:p>
-        </p:txBody>
-      </p:sp>
-      <p:sp>
-        <p:nvSpPr>
-          <p:cNvPr id="10" name="Text 7"/>
-          <p:cNvSpPr txBox="1"/>
-          <p:nvPr/>
-        </p:nvSpPr>
-        <p:spPr>
-          <a:xfrm>
-            <a:off x="685800" y="3505200"/>
-            <a:ext cx="4762500" cy="876300"/>
-          </a:xfrm>
-          <a:prstGeom prst="rect">
-            <a:avLst/>
-          </a:prstGeom>
-          <a:noFill/>
-          <a:ln/>
-        </p:spPr>
-        <p:txBody>
-          <a:bodyPr wrap="square" lIns="0" tIns="0" rIns="0" bIns="0" rtlCol="0" anchor="t"/>
-          <a:lstStyle/>
-          <a:p>
-            <a:pPr indent="0" marL="0">
-              <a:lnSpc>
-                <a:spcPct val="115000"/>
-              </a:lnSpc>
-              <a:buNone/>
-            </a:pPr>
-            <a:r>
-              <a:rPr lang="en-US" sz="1600" dirty="0">
-                <a:solidFill>
-                  <a:srgbClr val="BDC4D2"/>
-                </a:solidFill>
-                <a:latin typeface="Calibri" pitchFamily="34" charset="0"/>
-                <a:ea typeface="Calibri" pitchFamily="34" charset="-122"/>
-                <a:cs typeface="Calibri" pitchFamily="34" charset="-120"/>
-              </a:rPr>
-              <a:t>Рабочий сервис записи в MAX из одного сообщения — без разработчика, без подрядчика, без ожидания.</a:t>
-            </a:r>
-            <a:endParaRPr lang="en-US" sz="1600" dirty="0"/>
-          </a:p>
-        </p:txBody>
-      </p:sp>
-      <p:sp>
-        <p:nvSpPr>
-          <p:cNvPr id="11" name="Text 8"/>
-          <p:cNvSpPr txBox="1"/>
-          <p:nvPr/>
-        </p:nvSpPr>
-        <p:spPr>
-          <a:xfrm>
-            <a:off x="685800" y="4810125"/>
-            <a:ext cx="1905000" cy="152400"/>
-          </a:xfrm>
-          <a:prstGeom prst="rect">
-            <a:avLst/>
-          </a:prstGeom>
-          <a:noFill/>
-          <a:ln/>
-        </p:spPr>
-        <p:txBody>
-          <a:bodyPr wrap="square" lIns="0" tIns="0" rIns="0" bIns="0" rtlCol="0" anchor="ctr"/>
-          <a:lstStyle/>
-          <a:p>
-            <a:pPr indent="0" marL="0">
-              <a:buNone/>
-            </a:pPr>
-            <a:r>
-              <a:rPr lang="en-US" sz="860" b="1" spc="200" kern="0" dirty="0">
-                <a:solidFill>
-                  <a:srgbClr val="7B8190"/>
-                </a:solidFill>
-                <a:latin typeface="Calibri" pitchFamily="34" charset="0"/>
-                <a:ea typeface="Calibri" pitchFamily="34" charset="-122"/>
-                <a:cs typeface="Calibri" pitchFamily="34" charset="-120"/>
-              </a:rPr>
-              <a:t>КОМАНДА</a:t>
-            </a:r>
-            <a:endParaRPr lang="en-US" sz="860" dirty="0"/>
-          </a:p>
-        </p:txBody>
-      </p:sp>
-      <p:sp>
-        <p:nvSpPr>
-          <p:cNvPr id="12" name="Text 9"/>
-          <p:cNvSpPr txBox="1"/>
-          <p:nvPr/>
-        </p:nvSpPr>
-        <p:spPr>
-          <a:xfrm>
-            <a:off x="685800" y="5029200"/>
-            <a:ext cx="2000250" cy="228600"/>
-          </a:xfrm>
-          <a:prstGeom prst="rect">
-            <a:avLst/>
-          </a:prstGeom>
-          <a:noFill/>
-          <a:ln/>
-        </p:spPr>
-        <p:txBody>
-          <a:bodyPr wrap="square" lIns="0" tIns="0" rIns="0" bIns="0" rtlCol="0" anchor="ctr"/>
-          <a:lstStyle/>
-          <a:p>
-            <a:pPr indent="0" marL="0">
-              <a:buNone/>
-            </a:pPr>
-            <a:r>
-              <a:rPr lang="en-US" sz="1275" b="1" u="dash" dirty="0">
-                <a:solidFill>
-                  <a:srgbClr val="8F96A6"/>
-                </a:solidFill>
-                <a:uFill>
-                  <a:solidFill>
-                    <a:srgbClr val="59627A"/>
-                  </a:solidFill>
-                </a:uFill>
-                <a:latin typeface="Calibri" pitchFamily="34" charset="0"/>
-                <a:ea typeface="Calibri" pitchFamily="34" charset="-122"/>
-                <a:cs typeface="Calibri" pitchFamily="34" charset="-120"/>
-              </a:rPr>
-              <a:t>[Название команды]</a:t>
-            </a:r>
-            <a:endParaRPr lang="en-US" sz="1275" dirty="0"/>
-          </a:p>
-        </p:txBody>
-      </p:sp>
-      <p:sp>
-        <p:nvSpPr>
-          <p:cNvPr id="13" name="Text 10"/>
-          <p:cNvSpPr txBox="1"/>
-          <p:nvPr/>
-        </p:nvSpPr>
-        <p:spPr>
-          <a:xfrm>
-            <a:off x="685800" y="5295900"/>
-            <a:ext cx="2000250" cy="190500"/>
-          </a:xfrm>
-          <a:prstGeom prst="rect">
-            <a:avLst/>
-          </a:prstGeom>
-          <a:noFill/>
-          <a:ln/>
-        </p:spPr>
-        <p:txBody>
-          <a:bodyPr wrap="square" lIns="0" tIns="0" rIns="0" bIns="0" rtlCol="0" anchor="ctr"/>
-          <a:lstStyle/>
-          <a:p>
-            <a:pPr indent="0" marL="0">
-              <a:buNone/>
-            </a:pPr>
-            <a:r>
-              <a:rPr lang="en-US" sz="1000" u="dash" dirty="0">
-                <a:solidFill>
-                  <a:srgbClr val="8F96A6"/>
-                </a:solidFill>
-                <a:uFill>
-                  <a:solidFill>
-                    <a:srgbClr val="59627A"/>
-                  </a:solidFill>
-                </a:uFill>
-                <a:latin typeface="Calibri" pitchFamily="34" charset="0"/>
-                <a:ea typeface="Calibri" pitchFamily="34" charset="-122"/>
-                <a:cs typeface="Calibri" pitchFamily="34" charset="-120"/>
-              </a:rPr>
-              <a:t>[Участники и роли]</a:t>
-            </a:r>
-            <a:endParaRPr lang="en-US" sz="1000" dirty="0"/>
-          </a:p>
-        </p:txBody>
-      </p:sp>
-      <p:sp>
-        <p:nvSpPr>
-          <p:cNvPr id="14" name="Text 11"/>
-          <p:cNvSpPr txBox="1"/>
-          <p:nvPr/>
-        </p:nvSpPr>
-        <p:spPr>
-          <a:xfrm>
-            <a:off x="2838450" y="4810125"/>
-            <a:ext cx="2381250" cy="152400"/>
-          </a:xfrm>
-          <a:prstGeom prst="rect">
-            <a:avLst/>
-          </a:prstGeom>
-          <a:noFill/>
-          <a:ln/>
-        </p:spPr>
-        <p:txBody>
-          <a:bodyPr wrap="square" lIns="0" tIns="0" rIns="0" bIns="0" rtlCol="0" anchor="ctr"/>
-          <a:lstStyle/>
-          <a:p>
-            <a:pPr indent="0" marL="0">
-              <a:buNone/>
-            </a:pPr>
-            <a:r>
-              <a:rPr lang="en-US" sz="860" b="1" spc="200" kern="0" dirty="0">
-                <a:solidFill>
-                  <a:srgbClr val="7B8190"/>
-                </a:solidFill>
-                <a:latin typeface="Calibri" pitchFamily="34" charset="0"/>
-                <a:ea typeface="Calibri" pitchFamily="34" charset="-122"/>
-                <a:cs typeface="Calibri" pitchFamily="34" charset="-120"/>
-              </a:rPr>
-              <a:t>РЕШЕНИЕ</a:t>
-            </a:r>
-            <a:endParaRPr lang="en-US" sz="860" dirty="0"/>
-          </a:p>
-        </p:txBody>
-      </p:sp>
-      <p:sp>
-        <p:nvSpPr>
-          <p:cNvPr id="15" name="Text 12"/>
-          <p:cNvSpPr txBox="1"/>
-          <p:nvPr/>
-        </p:nvSpPr>
-        <p:spPr>
-          <a:xfrm>
-            <a:off x="2838450" y="5029200"/>
-            <a:ext cx="2571750" cy="228600"/>
-          </a:xfrm>
-          <a:prstGeom prst="rect">
-            <a:avLst/>
-          </a:prstGeom>
-          <a:noFill/>
-          <a:ln/>
-        </p:spPr>
-        <p:txBody>
-          <a:bodyPr wrap="square" lIns="0" tIns="0" rIns="0" bIns="0" rtlCol="0" anchor="ctr"/>
-          <a:lstStyle/>
-          <a:p>
-            <a:pPr indent="0" marL="0">
-              <a:buNone/>
-            </a:pPr>
-            <a:r>
-              <a:rPr lang="en-US" sz="1275" b="1" dirty="0">
-                <a:solidFill>
-                  <a:srgbClr val="FFFFFF"/>
-                </a:solidFill>
-                <a:latin typeface="Calibri" pitchFamily="34" charset="0"/>
-                <a:ea typeface="Calibri" pitchFamily="34" charset="-122"/>
-                <a:cs typeface="Calibri" pitchFamily="34" charset="-120"/>
-              </a:rPr>
-              <a:t>Чат-бот + мини-приложение</a:t>
-            </a:r>
-            <a:endParaRPr lang="en-US" sz="1275" dirty="0"/>
-          </a:p>
-        </p:txBody>
-      </p:sp>
-      <p:sp>
-        <p:nvSpPr>
-          <p:cNvPr id="16" name="Text 13"/>
-          <p:cNvSpPr txBox="1"/>
-          <p:nvPr/>
-        </p:nvSpPr>
-        <p:spPr>
-          <a:xfrm>
-            <a:off x="2838450" y="5295900"/>
-            <a:ext cx="2571750" cy="190500"/>
-          </a:xfrm>
-          <a:prstGeom prst="rect">
-            <a:avLst/>
-          </a:prstGeom>
-          <a:noFill/>
-          <a:ln/>
-        </p:spPr>
-        <p:txBody>
-          <a:bodyPr wrap="square" lIns="0" tIns="0" rIns="0" bIns="0" rtlCol="0" anchor="ctr"/>
-          <a:lstStyle/>
-          <a:p>
-            <a:pPr indent="0" marL="0">
-              <a:buNone/>
-            </a:pPr>
-            <a:r>
-              <a:rPr lang="en-US" sz="1000" dirty="0">
-                <a:solidFill>
-                  <a:srgbClr val="A5ACBC"/>
-                </a:solidFill>
-                <a:latin typeface="Calibri" pitchFamily="34" charset="0"/>
-                <a:ea typeface="Calibri" pitchFamily="34" charset="-122"/>
-                <a:cs typeface="Calibri" pitchFamily="34" charset="-120"/>
-              </a:rPr>
-              <a:t>@t403_hakaton_max_bot</a:t>
-            </a:r>
-            <a:endParaRPr lang="en-US" sz="1000" dirty="0"/>
-          </a:p>
-        </p:txBody>
-      </p:sp>
-      <p:sp>
-        <p:nvSpPr>
-          <p:cNvPr id="17" name="Text 14"/>
-          <p:cNvSpPr txBox="1"/>
-          <p:nvPr/>
-        </p:nvSpPr>
-        <p:spPr>
-          <a:xfrm>
-            <a:off x="5848350" y="990600"/>
-            <a:ext cx="2857500" cy="152400"/>
-          </a:xfrm>
-          <a:prstGeom prst="rect">
-            <a:avLst/>
-          </a:prstGeom>
-          <a:noFill/>
-          <a:ln/>
-        </p:spPr>
-        <p:txBody>
-          <a:bodyPr wrap="square" lIns="0" tIns="0" rIns="0" bIns="0" rtlCol="0" anchor="ctr"/>
-          <a:lstStyle/>
-          <a:p>
-            <a:pPr indent="0" marL="0">
-              <a:buNone/>
-            </a:pPr>
-            <a:r>
-              <a:rPr lang="en-US" sz="825" b="1" spc="200" kern="0" dirty="0">
-                <a:solidFill>
-                  <a:srgbClr val="7B8190"/>
-                </a:solidFill>
-                <a:latin typeface="Calibri" pitchFamily="34" charset="0"/>
-                <a:ea typeface="Calibri" pitchFamily="34" charset="-122"/>
-                <a:cs typeface="Calibri" pitchFamily="34" charset="-120"/>
-              </a:rPr>
-              <a:t>ВЛАДЕЛЕЦ ОПИСЫВАЕТ БИЗНЕС</a:t>
-            </a:r>
-            <a:endParaRPr lang="en-US" sz="825" dirty="0"/>
-          </a:p>
-        </p:txBody>
-      </p:sp>
       <p:pic>
         <p:nvPicPr>
-          <p:cNvPr id="18" name="Image 1" descr="bubble-owner.png">    </p:cNvPr>
+          <p:cNvPr id="5" name="Image 1" descr="mark-max.png">    </p:cNvPr>
           <p:cNvPicPr>
             <a:picLocks noChangeAspect="1"/>
           </p:cNvPicPr>
@@ -16489,6 +15997,472 @@
         </p:blipFill>
         <p:spPr>
           <a:xfrm>
+            <a:off x="2371725" y="1333500"/>
+            <a:ext cx="304800" cy="304800"/>
+          </a:xfrm>
+          <a:prstGeom prst="rect">
+            <a:avLst/>
+          </a:prstGeom>
+        </p:spPr>
+      </p:pic>
+      <p:sp>
+        <p:nvSpPr>
+          <p:cNvPr id="6" name="Text 2"/>
+          <p:cNvSpPr txBox="1"/>
+          <p:nvPr/>
+        </p:nvSpPr>
+        <p:spPr>
+          <a:xfrm>
+            <a:off x="2752725" y="1333500"/>
+            <a:ext cx="762000" cy="304800"/>
+          </a:xfrm>
+          <a:prstGeom prst="rect">
+            <a:avLst/>
+          </a:prstGeom>
+          <a:noFill/>
+          <a:ln/>
+        </p:spPr>
+        <p:txBody>
+          <a:bodyPr wrap="square" lIns="0" tIns="0" rIns="0" bIns="0" rtlCol="0" anchor="ctr"/>
+          <a:lstStyle/>
+          <a:p>
+            <a:pPr indent="0" marL="0">
+              <a:buNone/>
+            </a:pPr>
+            <a:r>
+              <a:rPr lang="en-US" sz="1600" b="1" dirty="0">
+                <a:solidFill>
+                  <a:srgbClr val="FFFFFF"/>
+                </a:solidFill>
+                <a:latin typeface="Calibri" pitchFamily="34" charset="0"/>
+                <a:ea typeface="Calibri" pitchFamily="34" charset="-122"/>
+                <a:cs typeface="Calibri" pitchFamily="34" charset="-120"/>
+              </a:rPr>
+              <a:t>max</a:t>
+            </a:r>
+            <a:endParaRPr lang="en-US" sz="1600" dirty="0"/>
+          </a:p>
+        </p:txBody>
+      </p:sp>
+      <p:sp>
+        <p:nvSpPr>
+          <p:cNvPr id="7" name="Text 3"/>
+          <p:cNvSpPr txBox="1"/>
+          <p:nvPr/>
+        </p:nvSpPr>
+        <p:spPr>
+          <a:xfrm>
+            <a:off x="685800" y="1943100"/>
+            <a:ext cx="4953000" cy="190500"/>
+          </a:xfrm>
+          <a:prstGeom prst="rect">
+            <a:avLst/>
+          </a:prstGeom>
+          <a:noFill/>
+          <a:ln/>
+        </p:spPr>
+        <p:txBody>
+          <a:bodyPr wrap="square" lIns="0" tIns="0" rIns="0" bIns="0" rtlCol="0" anchor="ctr"/>
+          <a:lstStyle/>
+          <a:p>
+            <a:pPr indent="0" marL="0">
+              <a:buNone/>
+            </a:pPr>
+            <a:r>
+              <a:rPr lang="en-US" sz="860" b="1" spc="200" kern="0" dirty="0">
+                <a:solidFill>
+                  <a:srgbClr val="8EC4FF"/>
+                </a:solidFill>
+                <a:latin typeface="Calibri" pitchFamily="34" charset="0"/>
+                <a:ea typeface="Calibri" pitchFamily="34" charset="-122"/>
+                <a:cs typeface="Calibri" pitchFamily="34" charset="-120"/>
+              </a:rPr>
+              <a:t>ТРЕК «ЭФФЕКТИВНЫЙ БИЗНЕС»</a:t>
+            </a:r>
+            <a:endParaRPr lang="en-US" sz="860" dirty="0"/>
+          </a:p>
+        </p:txBody>
+      </p:sp>
+      <p:sp>
+        <p:nvSpPr>
+          <p:cNvPr id="8" name="Text 4"/>
+          <p:cNvSpPr txBox="1"/>
+          <p:nvPr/>
+        </p:nvSpPr>
+        <p:spPr>
+          <a:xfrm>
+            <a:off x="647700" y="2152650"/>
+            <a:ext cx="5334000" cy="1181100"/>
+          </a:xfrm>
+          <a:prstGeom prst="rect">
+            <a:avLst/>
+          </a:prstGeom>
+          <a:noFill/>
+          <a:ln/>
+        </p:spPr>
+        <p:txBody>
+          <a:bodyPr wrap="square" lIns="0" tIns="0" rIns="0" bIns="0" rtlCol="0" anchor="t"/>
+          <a:lstStyle/>
+          <a:p>
+            <a:pPr indent="0" marL="0">
+              <a:buNone/>
+            </a:pPr>
+            <a:r>
+              <a:rPr lang="en-US" sz="6400" b="1" dirty="0">
+                <a:solidFill>
+                  <a:srgbClr val="FFFFFF"/>
+                </a:solidFill>
+                <a:latin typeface="Calibri" pitchFamily="34" charset="0"/>
+                <a:ea typeface="Calibri" pitchFamily="34" charset="-122"/>
+                <a:cs typeface="Calibri" pitchFamily="34" charset="-120"/>
+              </a:rPr>
+              <a:t>AIRuntime</a:t>
+            </a:r>
+            <a:endParaRPr lang="en-US" sz="6400" dirty="0"/>
+          </a:p>
+        </p:txBody>
+      </p:sp>
+      <p:sp>
+        <p:nvSpPr>
+          <p:cNvPr id="9" name="Text 5"/>
+          <p:cNvSpPr txBox="1"/>
+          <p:nvPr/>
+        </p:nvSpPr>
+        <p:spPr>
+          <a:xfrm>
+            <a:off x="685800" y="3505200"/>
+            <a:ext cx="4762500" cy="876300"/>
+          </a:xfrm>
+          <a:prstGeom prst="rect">
+            <a:avLst/>
+          </a:prstGeom>
+          <a:noFill/>
+          <a:ln/>
+        </p:spPr>
+        <p:txBody>
+          <a:bodyPr wrap="square" lIns="0" tIns="0" rIns="0" bIns="0" rtlCol="0" anchor="t"/>
+          <a:lstStyle/>
+          <a:p>
+            <a:pPr indent="0" marL="0">
+              <a:lnSpc>
+                <a:spcPct val="115000"/>
+              </a:lnSpc>
+              <a:buNone/>
+            </a:pPr>
+            <a:r>
+              <a:rPr lang="en-US" sz="1600" dirty="0">
+                <a:solidFill>
+                  <a:srgbClr val="BDC4D2"/>
+                </a:solidFill>
+                <a:latin typeface="Calibri" pitchFamily="34" charset="0"/>
+                <a:ea typeface="Calibri" pitchFamily="34" charset="-122"/>
+                <a:cs typeface="Calibri" pitchFamily="34" charset="-120"/>
+              </a:rPr>
+              <a:t>Рабочий сервис записи в MAX из одного сообщения — без разработчика, без подрядчика, без ожидания.</a:t>
+            </a:r>
+            <a:endParaRPr lang="en-US" sz="1600" dirty="0"/>
+          </a:p>
+        </p:txBody>
+      </p:sp>
+      <p:sp>
+        <p:nvSpPr>
+          <p:cNvPr id="10" name="Text 6"/>
+          <p:cNvSpPr txBox="1"/>
+          <p:nvPr/>
+        </p:nvSpPr>
+        <p:spPr>
+          <a:xfrm>
+            <a:off x="685800" y="4810125"/>
+            <a:ext cx="1905000" cy="152400"/>
+          </a:xfrm>
+          <a:prstGeom prst="rect">
+            <a:avLst/>
+          </a:prstGeom>
+          <a:noFill/>
+          <a:ln/>
+        </p:spPr>
+        <p:txBody>
+          <a:bodyPr wrap="square" lIns="0" tIns="0" rIns="0" bIns="0" rtlCol="0" anchor="ctr"/>
+          <a:lstStyle/>
+          <a:p>
+            <a:pPr indent="0" marL="0">
+              <a:buNone/>
+            </a:pPr>
+            <a:r>
+              <a:rPr lang="en-US" sz="860" b="1" spc="200" kern="0" dirty="0">
+                <a:solidFill>
+                  <a:srgbClr val="7B8190"/>
+                </a:solidFill>
+                <a:latin typeface="Calibri" pitchFamily="34" charset="0"/>
+                <a:ea typeface="Calibri" pitchFamily="34" charset="-122"/>
+                <a:cs typeface="Calibri" pitchFamily="34" charset="-120"/>
+              </a:rPr>
+              <a:t>КОМАНДА</a:t>
+            </a:r>
+            <a:endParaRPr lang="en-US" sz="860" dirty="0"/>
+          </a:p>
+        </p:txBody>
+      </p:sp>
+      <p:sp>
+        <p:nvSpPr>
+          <p:cNvPr id="11" name="Text 7"/>
+          <p:cNvSpPr txBox="1"/>
+          <p:nvPr/>
+        </p:nvSpPr>
+        <p:spPr>
+          <a:xfrm>
+            <a:off x="685800" y="5029200"/>
+            <a:ext cx="2000250" cy="228600"/>
+          </a:xfrm>
+          <a:prstGeom prst="rect">
+            <a:avLst/>
+          </a:prstGeom>
+          <a:noFill/>
+          <a:ln/>
+        </p:spPr>
+        <p:txBody>
+          <a:bodyPr wrap="square" lIns="0" tIns="0" rIns="0" bIns="0" rtlCol="0" anchor="ctr"/>
+          <a:lstStyle/>
+          <a:p>
+            <a:pPr indent="0" marL="0">
+              <a:buNone/>
+            </a:pPr>
+            <a:r>
+              <a:rPr lang="en-US" sz="1275" b="1" u="dash" dirty="0">
+                <a:solidFill>
+                  <a:srgbClr val="8F96A6"/>
+                </a:solidFill>
+                <a:uFill>
+                  <a:solidFill>
+                    <a:srgbClr val="59627A"/>
+                  </a:solidFill>
+                </a:uFill>
+                <a:latin typeface="Calibri" pitchFamily="34" charset="0"/>
+                <a:ea typeface="Calibri" pitchFamily="34" charset="-122"/>
+                <a:cs typeface="Calibri" pitchFamily="34" charset="-120"/>
+              </a:rPr>
+              <a:t>[Название команды]</a:t>
+            </a:r>
+            <a:endParaRPr lang="en-US" sz="1275" dirty="0"/>
+          </a:p>
+        </p:txBody>
+      </p:sp>
+      <p:sp>
+        <p:nvSpPr>
+          <p:cNvPr id="12" name="Text 8"/>
+          <p:cNvSpPr txBox="1"/>
+          <p:nvPr/>
+        </p:nvSpPr>
+        <p:spPr>
+          <a:xfrm>
+            <a:off x="685800" y="5295900"/>
+            <a:ext cx="2000250" cy="190500"/>
+          </a:xfrm>
+          <a:prstGeom prst="rect">
+            <a:avLst/>
+          </a:prstGeom>
+          <a:noFill/>
+          <a:ln/>
+        </p:spPr>
+        <p:txBody>
+          <a:bodyPr wrap="square" lIns="0" tIns="0" rIns="0" bIns="0" rtlCol="0" anchor="ctr"/>
+          <a:lstStyle/>
+          <a:p>
+            <a:pPr indent="0" marL="0">
+              <a:buNone/>
+            </a:pPr>
+            <a:r>
+              <a:rPr lang="en-US" sz="1000" u="dash" dirty="0">
+                <a:solidFill>
+                  <a:srgbClr val="8F96A6"/>
+                </a:solidFill>
+                <a:uFill>
+                  <a:solidFill>
+                    <a:srgbClr val="59627A"/>
+                  </a:solidFill>
+                </a:uFill>
+                <a:latin typeface="Calibri" pitchFamily="34" charset="0"/>
+                <a:ea typeface="Calibri" pitchFamily="34" charset="-122"/>
+                <a:cs typeface="Calibri" pitchFamily="34" charset="-120"/>
+              </a:rPr>
+              <a:t>[Участники и роли]</a:t>
+            </a:r>
+            <a:endParaRPr lang="en-US" sz="1000" dirty="0"/>
+          </a:p>
+        </p:txBody>
+      </p:sp>
+      <p:sp>
+        <p:nvSpPr>
+          <p:cNvPr id="13" name="Text 9"/>
+          <p:cNvSpPr txBox="1"/>
+          <p:nvPr/>
+        </p:nvSpPr>
+        <p:spPr>
+          <a:xfrm>
+            <a:off x="2838450" y="4810125"/>
+            <a:ext cx="2381250" cy="152400"/>
+          </a:xfrm>
+          <a:prstGeom prst="rect">
+            <a:avLst/>
+          </a:prstGeom>
+          <a:noFill/>
+          <a:ln/>
+        </p:spPr>
+        <p:txBody>
+          <a:bodyPr wrap="square" lIns="0" tIns="0" rIns="0" bIns="0" rtlCol="0" anchor="ctr"/>
+          <a:lstStyle/>
+          <a:p>
+            <a:pPr indent="0" marL="0">
+              <a:buNone/>
+            </a:pPr>
+            <a:r>
+              <a:rPr lang="en-US" sz="860" b="1" spc="200" kern="0" dirty="0">
+                <a:solidFill>
+                  <a:srgbClr val="7B8190"/>
+                </a:solidFill>
+                <a:latin typeface="Calibri" pitchFamily="34" charset="0"/>
+                <a:ea typeface="Calibri" pitchFamily="34" charset="-122"/>
+                <a:cs typeface="Calibri" pitchFamily="34" charset="-120"/>
+              </a:rPr>
+              <a:t>РЕШЕНИЕ</a:t>
+            </a:r>
+            <a:endParaRPr lang="en-US" sz="860" dirty="0"/>
+          </a:p>
+        </p:txBody>
+      </p:sp>
+      <p:sp>
+        <p:nvSpPr>
+          <p:cNvPr id="14" name="Text 10"/>
+          <p:cNvSpPr txBox="1"/>
+          <p:nvPr/>
+        </p:nvSpPr>
+        <p:spPr>
+          <a:xfrm>
+            <a:off x="2838450" y="5029200"/>
+            <a:ext cx="2571750" cy="228600"/>
+          </a:xfrm>
+          <a:prstGeom prst="rect">
+            <a:avLst/>
+          </a:prstGeom>
+          <a:noFill/>
+          <a:ln/>
+        </p:spPr>
+        <p:txBody>
+          <a:bodyPr wrap="square" lIns="0" tIns="0" rIns="0" bIns="0" rtlCol="0" anchor="ctr"/>
+          <a:lstStyle/>
+          <a:p>
+            <a:pPr indent="0" marL="0">
+              <a:buNone/>
+            </a:pPr>
+            <a:r>
+              <a:rPr lang="en-US" sz="1275" b="1" dirty="0">
+                <a:solidFill>
+                  <a:srgbClr val="FFFFFF"/>
+                </a:solidFill>
+                <a:latin typeface="Calibri" pitchFamily="34" charset="0"/>
+                <a:ea typeface="Calibri" pitchFamily="34" charset="-122"/>
+                <a:cs typeface="Calibri" pitchFamily="34" charset="-120"/>
+              </a:rPr>
+              <a:t>Чат-бот + мини-приложение</a:t>
+            </a:r>
+            <a:endParaRPr lang="en-US" sz="1275" dirty="0"/>
+          </a:p>
+        </p:txBody>
+      </p:sp>
+      <p:sp>
+        <p:nvSpPr>
+          <p:cNvPr id="15" name="Text 11"/>
+          <p:cNvSpPr txBox="1"/>
+          <p:nvPr/>
+        </p:nvSpPr>
+        <p:spPr>
+          <a:xfrm>
+            <a:off x="2838450" y="5295900"/>
+            <a:ext cx="2571750" cy="190500"/>
+          </a:xfrm>
+          <a:prstGeom prst="rect">
+            <a:avLst/>
+          </a:prstGeom>
+          <a:noFill/>
+          <a:ln/>
+        </p:spPr>
+        <p:txBody>
+          <a:bodyPr wrap="square" lIns="0" tIns="0" rIns="0" bIns="0" rtlCol="0" anchor="ctr"/>
+          <a:lstStyle/>
+          <a:p>
+            <a:pPr indent="0" marL="0">
+              <a:buNone/>
+            </a:pPr>
+            <a:r>
+              <a:rPr lang="en-US" sz="1000" dirty="0">
+                <a:solidFill>
+                  <a:srgbClr val="A5ACBC"/>
+                </a:solidFill>
+                <a:latin typeface="Calibri" pitchFamily="34" charset="0"/>
+                <a:ea typeface="Calibri" pitchFamily="34" charset="-122"/>
+                <a:cs typeface="Calibri" pitchFamily="34" charset="-120"/>
+              </a:rPr>
+              <a:t>@t403_hakaton_max_bot</a:t>
+            </a:r>
+            <a:endParaRPr lang="en-US" sz="1000" dirty="0"/>
+          </a:p>
+        </p:txBody>
+      </p:sp>
+      <p:sp>
+        <p:nvSpPr>
+          <p:cNvPr id="16" name="Text 12"/>
+          <p:cNvSpPr txBox="1"/>
+          <p:nvPr/>
+        </p:nvSpPr>
+        <p:spPr>
+          <a:xfrm>
+            <a:off x="5848350" y="990600"/>
+            <a:ext cx="2857500" cy="152400"/>
+          </a:xfrm>
+          <a:prstGeom prst="rect">
+            <a:avLst/>
+          </a:prstGeom>
+          <a:noFill/>
+          <a:ln/>
+        </p:spPr>
+        <p:txBody>
+          <a:bodyPr wrap="square" lIns="0" tIns="0" rIns="0" bIns="0" rtlCol="0" anchor="ctr"/>
+          <a:lstStyle/>
+          <a:p>
+            <a:pPr indent="0" marL="0">
+              <a:buNone/>
+            </a:pPr>
+            <a:r>
+              <a:rPr lang="en-US" sz="825" b="1" spc="200" kern="0" dirty="0">
+                <a:solidFill>
+                  <a:srgbClr val="7B8190"/>
+                </a:solidFill>
+                <a:latin typeface="Calibri" pitchFamily="34" charset="0"/>
+                <a:ea typeface="Calibri" pitchFamily="34" charset="-122"/>
+                <a:cs typeface="Calibri" pitchFamily="34" charset="-120"/>
+              </a:rPr>
+              <a:t>ВЛАДЕЛЕЦ ОПИСЫВАЕТ БИЗНЕС</a:t>
+            </a:r>
+            <a:endParaRPr lang="en-US" sz="825" dirty="0"/>
+          </a:p>
+        </p:txBody>
+      </p:sp>
+      <p:pic>
+        <p:nvPicPr>
+          <p:cNvPr id="17" name="Image 2" descr="bubble-owner.png">    </p:cNvPr>
+          <p:cNvPicPr>
+            <a:picLocks noChangeAspect="1"/>
+          </p:cNvPicPr>
+          <p:nvPr/>
+        </p:nvPicPr>
+        <p:blipFill>
+          <a:blip r:embed="rId4"/>
+          <a:stretch>
+            <a:fillRect/>
+          </a:stretch>
+        </p:blipFill>
+        <p:spPr>
+          <a:xfrm>
             <a:off x="5848350" y="1257300"/>
             <a:ext cx="2590800" cy="1047750"/>
           </a:xfrm>
@@ -16499,7 +16473,7 @@
       </p:pic>
       <p:sp>
         <p:nvSpPr>
-          <p:cNvPr id="19" name="Text 15"/>
+          <p:cNvPr id="18" name="Text 13"/>
           <p:cNvSpPr txBox="1"/>
           <p:nvPr/>
         </p:nvSpPr>
@@ -16541,7 +16515,7 @@
       </p:sp>
       <p:sp>
         <p:nvSpPr>
-          <p:cNvPr id="20" name="Shape 16"/>
+          <p:cNvPr id="19" name="Shape 14"/>
           <p:cNvSpPr/>
           <p:nvPr/>
         </p:nvSpPr>
@@ -16575,14 +16549,14 @@
       </p:sp>
       <p:pic>
         <p:nvPicPr>
-          <p:cNvPr id="21" name="Image 2" descr="screen-storefront.png">    </p:cNvPr>
+          <p:cNvPr id="20" name="Image 3" descr="screen-storefront.png">    </p:cNvPr>
           <p:cNvPicPr>
             <a:picLocks noChangeAspect="1"/>
           </p:cNvPicPr>
           <p:nvPr/>
         </p:nvPicPr>
         <p:blipFill>
-          <a:blip r:embed="rId4"/>
+          <a:blip r:embed="rId5"/>
           <a:stretch>
             <a:fillRect/>
           </a:stretch>
@@ -16599,7 +16573,7 @@
       </p:pic>
       <p:sp>
         <p:nvSpPr>
-          <p:cNvPr id="22" name="Shape 17"/>
+          <p:cNvPr id="21" name="Shape 15"/>
           <p:cNvSpPr/>
           <p:nvPr/>
         </p:nvSpPr>
@@ -16633,7 +16607,7 @@
       </p:sp>
       <p:sp>
         <p:nvSpPr>
-          <p:cNvPr id="23" name="Shape 18"/>
+          <p:cNvPr id="22" name="Shape 16"/>
           <p:cNvSpPr/>
           <p:nvPr/>
         </p:nvSpPr>
@@ -16658,7 +16632,7 @@
       </p:sp>
       <p:sp>
         <p:nvSpPr>
-          <p:cNvPr id="24" name="Text 19"/>
+          <p:cNvPr id="23" name="Text 17"/>
           <p:cNvSpPr txBox="1"/>
           <p:nvPr/>
         </p:nvSpPr>
@@ -16697,7 +16671,7 @@
       </p:sp>
       <p:sp>
         <p:nvSpPr>
-          <p:cNvPr id="25" name="Text 20"/>
+          <p:cNvPr id="24" name="Text 18"/>
           <p:cNvSpPr txBox="1"/>
           <p:nvPr/>
         </p:nvSpPr>
@@ -16728,7 +16702,7 @@
                 <a:ea typeface="Calibri" pitchFamily="34" charset="-122"/>
                 <a:cs typeface="Calibri" pitchFamily="34" charset="-120"/>
               </a:rPr>
-              <a:t>Витрина готова</a:t>
+              <a:t>AIRuntime готов</a:t>
             </a:r>
             <a:endParaRPr lang="en-US" sz="1250" dirty="0"/>
           </a:p>
@@ -16736,7 +16710,7 @@
       </p:sp>
       <p:sp>
         <p:nvSpPr>
-          <p:cNvPr id="26" name="Text 21"/>
+          <p:cNvPr id="25" name="Text 19"/>
           <p:cNvSpPr txBox="1"/>
           <p:nvPr/>
         </p:nvSpPr>
@@ -16778,7 +16752,7 @@
       </p:sp>
       <p:sp>
         <p:nvSpPr>
-          <p:cNvPr id="27" name="Shape 22"/>
+          <p:cNvPr id="26" name="Shape 20"/>
           <p:cNvSpPr/>
           <p:nvPr/>
         </p:nvSpPr>
@@ -16805,7 +16779,7 @@
       </p:sp>
       <p:sp>
         <p:nvSpPr>
-          <p:cNvPr id="28" name="Text 23"/>
+          <p:cNvPr id="27" name="Text 21"/>
           <p:cNvSpPr txBox="1"/>
           <p:nvPr/>
         </p:nvSpPr>
@@ -16844,7 +16818,7 @@
       </p:sp>
       <p:sp>
         <p:nvSpPr>
-          <p:cNvPr id="29" name="Text 24"/>
+          <p:cNvPr id="28" name="Text 22"/>
           <p:cNvSpPr txBox="1"/>
           <p:nvPr/>
         </p:nvSpPr>
@@ -16883,7 +16857,7 @@
       </p:sp>
       <p:sp>
         <p:nvSpPr>
-          <p:cNvPr id="30" name="Text 25"/>
+          <p:cNvPr id="29" name="Text 23"/>
           <p:cNvSpPr txBox="1"/>
           <p:nvPr/>
         </p:nvSpPr>
@@ -17236,7 +17210,7 @@
                 <a:ea typeface="Calibri" pitchFamily="34" charset="-122"/>
                 <a:cs typeface="Calibri" pitchFamily="34" charset="-120"/>
               </a:rPr>
-              <a:t>Один владелец на витрину, до 10 витрин</a:t>
+              <a:t>Один владелец на сервис, до 10 сервисов</a:t>
             </a:r>
             <a:endParaRPr lang="en-US" sz="1200" dirty="0"/>
           </a:p>
@@ -17718,7 +17692,7 @@
                 <a:ea typeface="Calibri" pitchFamily="34" charset="-122"/>
                 <a:cs typeface="Calibri" pitchFamily="34" charset="-120"/>
               </a:rPr>
-              <a:t> — витрина собирается шаблоном, сценарий не блокируется</a:t>
+              <a:t> — сервис собирается шаблоном, сценарий не блокируется</a:t>
             </a:r>
             <a:endParaRPr lang="en-US" sz="1200" dirty="0"/>
           </a:p>
@@ -17753,7 +17727,7 @@
                 <a:ea typeface="Calibri" pitchFamily="34" charset="-122"/>
                 <a:cs typeface="Calibri" pitchFamily="34" charset="-120"/>
               </a:rPr>
-              <a:t> — при росте нужна проверка содержимого витрин</a:t>
+              <a:t> — при росте нужна проверка содержимого сервисов</a:t>
             </a:r>
             <a:endParaRPr lang="en-US" sz="1200" dirty="0"/>
           </a:p>
@@ -17840,7 +17814,7 @@
                 <a:ea typeface="Calibri" pitchFamily="34" charset="-122"/>
                 <a:cs typeface="Calibri" pitchFamily="34" charset="-120"/>
               </a:rPr>
-              <a:t> сквозной путь «описание → витрина → запись → заявка владельцу → ответ клиенту» проходит на проде целиком и покрыт 54 автотестами — включая подделку подписи, чужой токен, просроченные параметры и запись на услугу, которой в витрине нет.</a:t>
+              <a:t> сквозной путь «описание → сервис → запись → заявка владельцу → ответ клиенту» проходит на проде целиком и покрыт 54 автотестами — включая подделку подписи, чужой токен, просроченные параметры и запись на услугу, которой в сервисе нет.</a:t>
             </a:r>
             <a:endParaRPr lang="en-US" sz="1250" dirty="0"/>
           </a:p>
@@ -18837,65 +18811,39 @@
           </a:p>
         </p:txBody>
       </p:sp>
-      <p:sp>
-        <p:nvSpPr>
-          <p:cNvPr id="5" name="Shape 2"/>
-          <p:cNvSpPr/>
-          <p:nvPr/>
-        </p:nvSpPr>
-        <p:spPr>
-          <a:xfrm>
-            <a:off x="2371725" y="1281113"/>
-            <a:ext cx="219075" cy="219075"/>
-          </a:xfrm>
-          <a:prstGeom prst="ellipse">
-            <a:avLst/>
-          </a:prstGeom>
-          <a:solidFill>
-            <a:srgbClr val="FFFFFF"/>
-          </a:solidFill>
-          <a:ln w="12700">
-            <a:solidFill>
-              <a:srgbClr val="FFFFFF"/>
-            </a:solidFill>
-            <a:prstDash val="solid"/>
-          </a:ln>
-        </p:spPr>
-      </p:sp>
-      <p:sp>
-        <p:nvSpPr>
-          <p:cNvPr id="6" name="Shape 3"/>
-          <p:cNvSpPr/>
-          <p:nvPr/>
-        </p:nvSpPr>
-        <p:spPr>
-          <a:xfrm>
-            <a:off x="2443163" y="1352550"/>
-            <a:ext cx="76200" cy="76200"/>
-          </a:xfrm>
-          <a:prstGeom prst="ellipse">
-            <a:avLst/>
-          </a:prstGeom>
-          <a:solidFill>
-            <a:srgbClr val="0077FF"/>
-          </a:solidFill>
-          <a:ln w="12700">
-            <a:solidFill>
-              <a:srgbClr val="0077FF"/>
-            </a:solidFill>
-            <a:prstDash val="solid"/>
-          </a:ln>
-        </p:spPr>
-      </p:sp>
-      <p:sp>
-        <p:nvSpPr>
-          <p:cNvPr id="7" name="Text 4"/>
-          <p:cNvSpPr txBox="1"/>
-          <p:nvPr/>
-        </p:nvSpPr>
-        <p:spPr>
-          <a:xfrm>
-            <a:off x="2667000" y="1238250"/>
+      <p:pic>
+        <p:nvPicPr>
+          <p:cNvPr id="5" name="Image 1" descr="mark-max.png">    </p:cNvPr>
+          <p:cNvPicPr>
+            <a:picLocks noChangeAspect="1"/>
+          </p:cNvPicPr>
+          <p:nvPr/>
+        </p:nvPicPr>
+        <p:blipFill>
+          <a:blip r:embed="rId3"/>
+          <a:stretch>
+            <a:fillRect/>
+          </a:stretch>
+        </p:blipFill>
+        <p:spPr>
+          <a:xfrm>
+            <a:off x="2371725" y="1238250"/>
+            <a:ext cx="304800" cy="304800"/>
+          </a:xfrm>
+          <a:prstGeom prst="rect">
+            <a:avLst/>
+          </a:prstGeom>
+        </p:spPr>
+      </p:pic>
+      <p:sp>
+        <p:nvSpPr>
+          <p:cNvPr id="6" name="Text 2"/>
+          <p:cNvSpPr txBox="1"/>
+          <p:nvPr/>
+        </p:nvSpPr>
+        <p:spPr>
+          <a:xfrm>
+            <a:off x="2752725" y="1238250"/>
             <a:ext cx="762000" cy="304800"/>
           </a:xfrm>
           <a:prstGeom prst="rect">
@@ -18928,7 +18876,7 @@
       </p:sp>
       <p:sp>
         <p:nvSpPr>
-          <p:cNvPr id="8" name="Text 5"/>
+          <p:cNvPr id="7" name="Text 3"/>
           <p:cNvSpPr txBox="1"/>
           <p:nvPr/>
         </p:nvSpPr>
@@ -18967,7 +18915,7 @@
       </p:sp>
       <p:sp>
         <p:nvSpPr>
-          <p:cNvPr id="9" name="Text 6"/>
+          <p:cNvPr id="8" name="Text 4"/>
           <p:cNvSpPr txBox="1"/>
           <p:nvPr/>
         </p:nvSpPr>
@@ -19029,7 +18977,7 @@
       </p:sp>
       <p:sp>
         <p:nvSpPr>
-          <p:cNvPr id="10" name="Text 7"/>
+          <p:cNvPr id="9" name="Text 5"/>
           <p:cNvSpPr txBox="1"/>
           <p:nvPr/>
         </p:nvSpPr>
@@ -19063,7 +19011,7 @@
                 <a:ea typeface="Calibri" pitchFamily="34" charset="-122"/>
                 <a:cs typeface="Calibri" pitchFamily="34" charset="-120"/>
               </a:rPr>
-              <a:t>Бот и мини-приложение работают прямо сейчас. Опишите бизнес одним сообщением — секунд через десять у клиентов будет витрина с записью, а у вас заявки в чате.</a:t>
+              <a:t>Бот и мини-приложение работают прямо сейчас. Опишите бизнес одним сообщением — секунд через десять у клиентов будет страница записи, а у вас заявки в чате.</a:t>
             </a:r>
             <a:endParaRPr lang="en-US" sz="1450" dirty="0"/>
           </a:p>
@@ -19071,7 +19019,7 @@
       </p:sp>
       <p:sp>
         <p:nvSpPr>
-          <p:cNvPr id="11" name="Text 8"/>
+          <p:cNvPr id="10" name="Text 6"/>
           <p:cNvSpPr txBox="1"/>
           <p:nvPr/>
         </p:nvSpPr>
@@ -19110,7 +19058,7 @@
       </p:sp>
       <p:sp>
         <p:nvSpPr>
-          <p:cNvPr id="12" name="Text 9"/>
+          <p:cNvPr id="11" name="Text 7"/>
           <p:cNvSpPr txBox="1"/>
           <p:nvPr/>
         </p:nvSpPr>
@@ -19149,7 +19097,7 @@
       </p:sp>
       <p:sp>
         <p:nvSpPr>
-          <p:cNvPr id="13" name="Text 10"/>
+          <p:cNvPr id="12" name="Text 8"/>
           <p:cNvSpPr txBox="1"/>
           <p:nvPr/>
         </p:nvSpPr>
@@ -19188,7 +19136,7 @@
       </p:sp>
       <p:sp>
         <p:nvSpPr>
-          <p:cNvPr id="14" name="Text 11"/>
+          <p:cNvPr id="13" name="Text 9"/>
           <p:cNvSpPr txBox="1"/>
           <p:nvPr/>
         </p:nvSpPr>
@@ -19227,7 +19175,7 @@
       </p:sp>
       <p:sp>
         <p:nvSpPr>
-          <p:cNvPr id="15" name="Text 12"/>
+          <p:cNvPr id="14" name="Text 10"/>
           <p:cNvSpPr txBox="1"/>
           <p:nvPr/>
         </p:nvSpPr>
@@ -19266,7 +19214,7 @@
       </p:sp>
       <p:sp>
         <p:nvSpPr>
-          <p:cNvPr id="16" name="Text 13"/>
+          <p:cNvPr id="15" name="Text 11"/>
           <p:cNvSpPr txBox="1"/>
           <p:nvPr/>
         </p:nvSpPr>
@@ -19305,7 +19253,7 @@
       </p:sp>
       <p:sp>
         <p:nvSpPr>
-          <p:cNvPr id="17" name="Shape 14"/>
+          <p:cNvPr id="16" name="Shape 12"/>
           <p:cNvSpPr/>
           <p:nvPr/>
         </p:nvSpPr>
@@ -19339,14 +19287,14 @@
       </p:sp>
       <p:pic>
         <p:nvPicPr>
-          <p:cNvPr id="18" name="Image 1" descr="qr-bot.png">    </p:cNvPr>
+          <p:cNvPr id="17" name="Image 2" descr="qr-bot.png">    </p:cNvPr>
           <p:cNvPicPr>
             <a:picLocks noChangeAspect="1"/>
           </p:cNvPicPr>
           <p:nvPr/>
         </p:nvPicPr>
         <p:blipFill>
-          <a:blip r:embed="rId3"/>
+          <a:blip r:embed="rId4"/>
           <a:stretch>
             <a:fillRect/>
           </a:stretch>
@@ -19363,7 +19311,7 @@
       </p:pic>
       <p:sp>
         <p:nvSpPr>
-          <p:cNvPr id="19" name="Text 15"/>
+          <p:cNvPr id="18" name="Text 13"/>
           <p:cNvSpPr txBox="1"/>
           <p:nvPr/>
         </p:nvSpPr>
@@ -19402,7 +19350,7 @@
       </p:sp>
       <p:sp>
         <p:nvSpPr>
-          <p:cNvPr id="20" name="Text 16"/>
+          <p:cNvPr id="19" name="Text 14"/>
           <p:cNvSpPr txBox="1"/>
           <p:nvPr/>
         </p:nvSpPr>
@@ -19436,7 +19384,7 @@
                 <a:ea typeface="Calibri" pitchFamily="34" charset="-122"/>
                 <a:cs typeface="Calibri" pitchFamily="34" charset="-120"/>
               </a:rPr>
-              <a:t>Откроется бот в MAX — опишите свой бизнес и получите витрину</a:t>
+              <a:t>Откроется бот в MAX — опишите свой бизнес и получите страницу записи</a:t>
             </a:r>
             <a:endParaRPr lang="en-US" sz="1100" dirty="0"/>
           </a:p>
@@ -19444,7 +19392,7 @@
       </p:sp>
       <p:sp>
         <p:nvSpPr>
-          <p:cNvPr id="21" name="Text 17"/>
+          <p:cNvPr id="20" name="Text 15"/>
           <p:cNvSpPr txBox="1"/>
           <p:nvPr/>
         </p:nvSpPr>
@@ -19505,7 +19453,7 @@
       </p:sp>
       <p:sp>
         <p:nvSpPr>
-          <p:cNvPr id="22" name="Text 18"/>
+          <p:cNvPr id="21" name="Text 16"/>
           <p:cNvSpPr txBox="1"/>
           <p:nvPr/>
         </p:nvSpPr>
@@ -19646,7 +19594,7 @@
                 <a:ea typeface="Calibri" pitchFamily="34" charset="-122"/>
                 <a:cs typeface="Calibri" pitchFamily="34" charset="-120"/>
               </a:rPr>
-              <a:t>Витрина: запись в MAX из одного сообщения</a:t>
+              <a:t>AIRuntime: запись в MAX из одного сообщения</a:t>
             </a:r>
             <a:endParaRPr lang="en-US" sz="3200" dirty="0"/>
           </a:p>
@@ -19688,7 +19636,7 @@
                 <a:ea typeface="Calibri" pitchFamily="34" charset="-122"/>
                 <a:cs typeface="Calibri" pitchFamily="34" charset="-120"/>
               </a:rPr>
-              <a:t>Владелец микробизнеса услуг описывает бизнес одним сообщением в мини-приложении MAX — через ~10 секунд у него опубликованная витрина с онлайн-записью. Клиенты записываются, не выходя из MAX, заявки приходят владельцу в чат.</a:t>
+              <a:t>Владелец микробизнеса услуг описывает бизнес одним сообщением в мини-приложении MAX — через ~10 секунд у него опубликованный сервис с онлайн-записью. Клиенты записываются, не выходя из MAX, заявки приходят владельцу в чат.</a:t>
             </a:r>
             <a:endParaRPr lang="en-US" sz="1500" dirty="0"/>
           </a:p>
@@ -20036,7 +19984,7 @@
                 <a:ea typeface="Calibri" pitchFamily="34" charset="-122"/>
                 <a:cs typeface="Calibri" pitchFamily="34" charset="-120"/>
               </a:rPr>
-              <a:t>Чат-бот и мини-приложение в MAX: описание → витрина с услугами, ценами и временем → запись → заявка владельцу → ответ клиенту.</a:t>
+              <a:t>Чат-бот и мини-приложение в MAX: описание → сервис с услугами, ценами и временем → запись → заявка владельцу → ответ клиенту.</a:t>
             </a:r>
             <a:endParaRPr lang="en-US" sz="1500" dirty="0"/>
           </a:p>
@@ -20267,7 +20215,7 @@
                 <a:ea typeface="Calibri" pitchFamily="34" charset="-122"/>
                 <a:cs typeface="Calibri" pitchFamily="34" charset="-120"/>
               </a:rPr>
-              <a:t>сообщение от владельца до готовой витрины</a:t>
+              <a:t>сообщение от владельца до готового AIRuntime</a:t>
             </a:r>
             <a:endParaRPr lang="en-US" sz="1100" dirty="0"/>
           </a:p>
@@ -24136,7 +24084,7 @@
         <p:spPr>
           <a:xfrm>
             <a:off x="6469380" y="1874520"/>
-            <a:ext cx="1380744" cy="246888"/>
+            <a:ext cx="1449324" cy="246888"/>
           </a:xfrm>
           <a:prstGeom prst="roundRect">
             <a:avLst>
@@ -24163,7 +24111,7 @@
         <p:spPr>
           <a:xfrm>
             <a:off x="6469380" y="1874520"/>
-            <a:ext cx="1380744" cy="246888"/>
+            <a:ext cx="1449324" cy="246888"/>
           </a:xfrm>
           <a:prstGeom prst="rect">
             <a:avLst/>
@@ -24187,7 +24135,7 @@
                 <a:ea typeface="Calibri" pitchFamily="34" charset="-122"/>
                 <a:cs typeface="Calibri" pitchFamily="34" charset="-120"/>
               </a:rPr>
-              <a:t>To Be — с Витриной</a:t>
+              <a:t>To Be — с AIRuntime</a:t>
             </a:r>
             <a:endParaRPr lang="en-US" sz="950" dirty="0"/>
           </a:p>
@@ -24244,7 +24192,7 @@
                 <a:ea typeface="Calibri" pitchFamily="34" charset="-122"/>
                 <a:cs typeface="Calibri" pitchFamily="34" charset="-120"/>
               </a:rPr>
-              <a:t> пересказ прайса: услуги и цены видны в витрине</a:t>
+              <a:t> пересказ прайса: услуги и цены видны в AIRuntime</a:t>
             </a:r>
             <a:endParaRPr lang="en-US" sz="1250" dirty="0"/>
           </a:p>
@@ -24495,7 +24443,7 @@
                 <a:ea typeface="Calibri" pitchFamily="34" charset="-122"/>
                 <a:cs typeface="Calibri" pitchFamily="34" charset="-120"/>
               </a:rPr>
-              <a:t> Если мы поможем владельцу микросервиса принимать записи витриной в MAX, собранной из одного сообщения, доля заявок, дошедших до подтверждения, вырастет, а время на переписку сократится — потому что клиент проходит путь сам, а владельцу остаётся одно решение. Как это проверить — слайд 11.</a:t>
+              <a:t> Если мы поможем владельцу микросервиса принимать записи через AIRuntime в MAX, собранной из одного сообщения, доля заявок, дошедших до подтверждения, вырастет, а время на переписку сократится — потому что клиент проходит путь сам, а владельцу остаётся одно решение. Как это проверить — слайд 11.</a:t>
             </a:r>
             <a:endParaRPr lang="en-US" sz="1350" dirty="0"/>
           </a:p>
@@ -24989,7 +24937,7 @@
                           <a:ea typeface="Calibri" pitchFamily="34" charset="-122"/>
                           <a:cs typeface="Calibri" pitchFamily="34" charset="-120"/>
                         </a:rPr>
-                        <a:t>ВИТРИНА В MAX</a:t>
+                        <a:t>AIRUNTIME В MAX</a:t>
                       </a:r>
                       <a:endParaRPr lang="en-US" sz="950" dirty="0">
                         <a:latin typeface="Calibri" charset="0"/>
@@ -26782,7 +26730,7 @@
                 <a:ea typeface="Calibri" pitchFamily="34" charset="-122"/>
                 <a:cs typeface="Calibri" pitchFamily="34" charset="-120"/>
               </a:rPr>
-              <a:t>Владелец: одно сообщение → опубликованная витрина</a:t>
+              <a:t>Владелец: одно сообщение → опубликованный сервис</a:t>
             </a:r>
             <a:endParaRPr lang="en-US" sz="3200" dirty="0"/>
           </a:p>
@@ -26824,7 +26772,7 @@
                 <a:ea typeface="Calibri" pitchFamily="34" charset="-122"/>
                 <a:cs typeface="Calibri" pitchFamily="34" charset="-120"/>
               </a:rPr>
-              <a:t>Вход — «Начать» в чат-боте, затем «Открыть Витрину». Регистрации нет: аккаунт MAX и есть вход.</a:t>
+              <a:t>Вход — «Начать» в чат-боте, затем «Открыть AIRuntime». Регистрации нет: аккаунт MAX и есть вход.</a:t>
             </a:r>
             <a:endParaRPr lang="en-US" sz="1400" dirty="0"/>
           </a:p>
@@ -27241,7 +27189,7 @@
                 <a:ea typeface="Calibri" pitchFamily="34" charset="-122"/>
                 <a:cs typeface="Calibri" pitchFamily="34" charset="-120"/>
               </a:rPr>
-              <a:t>«✓ Витрина готова»: ссылка, «Поделиться» в чаты MAX, «Посмотреть» глазами клиента.</a:t>
+              <a:t>«✓ AIRuntime готов»: ссылка, «Поделиться» в чаты MAX, «Посмотреть» глазами клиента.</a:t>
             </a:r>
             <a:endParaRPr lang="en-US" sz="1050" dirty="0"/>
           </a:p>
@@ -27493,7 +27441,7 @@
                 <a:ea typeface="Calibri" pitchFamily="34" charset="-122"/>
                 <a:cs typeface="Calibri" pitchFamily="34" charset="-120"/>
               </a:rPr>
-              <a:t>Клиент открывает ссылку или QR-код владельца — витрина сразу внутри MAX, без установки и регистрации.</a:t>
+              <a:t>Клиент открывает ссылку или QR-код владельца — сервис сразу внутри MAX, без установки и регистрации.</a:t>
             </a:r>
             <a:endParaRPr lang="en-US" sz="1400" dirty="0"/>
           </a:p>

</xml_diff>

<commit_message>
Repair the sentences the AIRuntime rename left ungrammatical
The rename swapped the product's name into places that named the artefact it
builds, which broke agreement ("записи через AIRuntime, собранной из одного
сообщения") and, on the architecture slide, claimed the platform itself is data.
AIRuntime is the product; what it builds is a сервис.

Both decks also state the measured cold build time: 125 s for the backend image,
78 s for the frontend, 26 s for the admin, so the whole `docker compose up
--build` stays inside the five minutes the track allows. The README adds that
`codex` and `preview` are behind the build-only profile and are not part of it.

Co-Authored-By: Claude Opus 5 <noreply@anthropic.com>
</commit_message>
<xml_diff>
--- a/docs/max-presentation/presentation.pptx
+++ b/docs/max-presentation/presentation.pptx
@@ -5623,7 +5623,7 @@
                 <a:ea typeface="Calibri" pitchFamily="34" charset="-122"/>
                 <a:cs typeface="Calibri" pitchFamily="34" charset="-120"/>
               </a:rPr>
-              <a:t> — открыл AIRuntime → отправил заявку</a:t>
+              <a:t> — открыл страницу записи → отправил заявку</a:t>
             </a:r>
             <a:endParaRPr lang="en-US" sz="1250" dirty="0"/>
           </a:p>
@@ -7351,7 +7351,7 @@
                 <a:ea typeface="Calibri" pitchFamily="34" charset="-122"/>
                 <a:cs typeface="Calibri" pitchFamily="34" charset="-120"/>
               </a:rPr>
-              <a:t>Код под каждый бизнес: AIRuntime — это данные</a:t>
+              <a:t>Код под каждый бизнес: сервис — это данные</a:t>
             </a:r>
             <a:endParaRPr lang="en-US" sz="1200" dirty="0"/>
           </a:p>
@@ -8910,7 +8910,7 @@
                 <a:ea typeface="Calibri" pitchFamily="34" charset="-122"/>
                 <a:cs typeface="Calibri" pitchFamily="34" charset="-120"/>
               </a:rPr>
-              <a:t>AIRuntime — это данные, а не код</a:t>
+              <a:t>Сервис — это данные, а не код</a:t>
             </a:r>
             <a:endParaRPr lang="en-US" sz="1350" dirty="0"/>
           </a:p>
@@ -10014,6 +10014,30 @@
                 <a:cs typeface="Calibri" pitchFamily="34" charset="-120"/>
               </a:rPr>
               <a:t>54 автотеста: подделка подписи, чужой токен, чужие сервисы, сквозной сценарий через HTTP</a:t>
+            </a:r>
+            <a:endParaRPr lang="en-US" sz="1150" dirty="0"/>
+          </a:p>
+          <a:p>
+            <a:pPr marL="190500" indent="-190500">
+              <a:lnSpc>
+                <a:spcPct val="108000"/>
+              </a:lnSpc>
+              <a:spcAft>
+                <a:spcPts val="600"/>
+              </a:spcAft>
+              <a:buSzPct val="100000"/>
+              <a:buChar char="•"/>
+            </a:pPr>
+            <a:r>
+              <a:rPr lang="en-US" sz="1150" dirty="0">
+                <a:solidFill>
+                  <a:srgbClr val="4A5464"/>
+                </a:solidFill>
+                <a:latin typeface="Calibri" pitchFamily="34" charset="0"/>
+                <a:ea typeface="Calibri" pitchFamily="34" charset="-122"/>
+                <a:cs typeface="Calibri" pitchFamily="34" charset="-120"/>
+              </a:rPr>
+              <a:t>Сборка образов с нуля — около 4 минут (замер), лимит задания — 5</a:t>
             </a:r>
             <a:endParaRPr lang="en-US" sz="1150" dirty="0"/>
           </a:p>
@@ -14719,7 +14743,7 @@
                 <a:ea typeface="Calibri" pitchFamily="34" charset="-122"/>
                 <a:cs typeface="Calibri" pitchFamily="34" charset="-120"/>
               </a:rPr>
-              <a:t> та же механика «одно сообщение → работающий сервис в MAX» подходит не только бизнесу — продуктовые команды проверяют гипотезы без разработки, люди делают небольшие сервисы для себя. Это ядро AIRuntime: первый вертикальный сценарий на этой механике.</a:t>
+              <a:t> та же механика «одно сообщение → работающий сервис в MAX» подходит не только бизнесу — продуктовые команды проверяют гипотезы без разработки, люди делают небольшие сервисы для себя. Это и есть ядро AIRuntime, а запись для микробизнеса — первый вертикальный сценарий на нём.</a:t>
             </a:r>
             <a:endParaRPr lang="en-US" sz="1150" dirty="0"/>
           </a:p>
@@ -20215,7 +20239,7 @@
                 <a:ea typeface="Calibri" pitchFamily="34" charset="-122"/>
                 <a:cs typeface="Calibri" pitchFamily="34" charset="-120"/>
               </a:rPr>
-              <a:t>сообщение от владельца до готового AIRuntime</a:t>
+              <a:t>сообщение от владельца до готового сервиса</a:t>
             </a:r>
             <a:endParaRPr lang="en-US" sz="1100" dirty="0"/>
           </a:p>
@@ -24192,7 +24216,7 @@
                 <a:ea typeface="Calibri" pitchFamily="34" charset="-122"/>
                 <a:cs typeface="Calibri" pitchFamily="34" charset="-120"/>
               </a:rPr>
-              <a:t> пересказ прайса: услуги и цены видны в AIRuntime</a:t>
+              <a:t> пересказ прайса: услуги и цены видны в самом сервисе</a:t>
             </a:r>
             <a:endParaRPr lang="en-US" sz="1250" dirty="0"/>
           </a:p>
@@ -24443,7 +24467,7 @@
                 <a:ea typeface="Calibri" pitchFamily="34" charset="-122"/>
                 <a:cs typeface="Calibri" pitchFamily="34" charset="-120"/>
               </a:rPr>
-              <a:t> Если мы поможем владельцу микросервиса принимать записи через AIRuntime в MAX, собранной из одного сообщения, доля заявок, дошедших до подтверждения, вырастет, а время на переписку сократится — потому что клиент проходит путь сам, а владельцу остаётся одно решение. Как это проверить — слайд 11.</a:t>
+              <a:t> Если мы поможем владельцу микросервиса принимать записи сервисом в MAX, собранным из одного сообщения, доля заявок, дошедших до подтверждения, вырастет, а время на переписку сократится — потому что клиент проходит путь сам, а владельцу остаётся одно решение. Как это проверить — слайд 11.</a:t>
             </a:r>
             <a:endParaRPr lang="en-US" sz="1350" dirty="0"/>
           </a:p>

</xml_diff>

<commit_message>
Reshoot the owner screens on the rebuilt composer
The screenshots in the deck were cut off along the right edge - they had been
taken with a viewport wider than the captured frame, so the composer's text and
the "+ Новая" button ran off the image. These are shot at 390x780 again, on the
composer as it ships now: the brief, the optional site, the optional files.

The slides quote the app, so the labels follow it: the button is «Собрать
страницу записи», and the scenario no longer promises ten seconds, since the
welcome message dropped that claim.

Co-Authored-By: Claude Opus 5 <noreply@anthropic.com>
</commit_message>
<xml_diff>
--- a/docs/max-presentation/presentation.pptx
+++ b/docs/max-presentation/presentation.pptx
@@ -3872,7 +3872,7 @@
                 <a:ea typeface="Calibri" pitchFamily="34" charset="-122"/>
                 <a:cs typeface="Calibri" pitchFamily="34" charset="-120"/>
               </a:rPr>
-              <a:t>: «Автосервис на Лесной. Диагностика 1500, замена масла 900, шиномонтаж 2400. Работаем с 9 до 20» — и нажать «Собрать AIRuntime»</a:t>
+              <a:t>: «Автосервис на Лесной. Диагностика 1500, замена масла 900, шиномонтаж 2400. Работаем с 9 до 20» — и нажать «Собрать страницу записи»</a:t>
             </a:r>
             <a:endParaRPr lang="en-US" sz="1250" dirty="0"/>
           </a:p>
@@ -3896,7 +3896,7 @@
                 <a:ea typeface="Calibri" pitchFamily="34" charset="-122"/>
                 <a:cs typeface="Calibri" pitchFamily="34" charset="-120"/>
               </a:rPr>
-              <a:t>Через ~10 секунд сервис опубликован: ссылка, «Поделиться», «Посмотреть»</a:t>
+              <a:t>Через несколько секунд страница опубликована: ссылка, «Поделиться», «Посмотреть»</a:t>
             </a:r>
             <a:endParaRPr lang="en-US" sz="1250" dirty="0"/>
           </a:p>
@@ -5055,7 +5055,7 @@
                 <a:ea typeface="Calibri" pitchFamily="34" charset="-122"/>
                 <a:cs typeface="Calibri" pitchFamily="34" charset="-120"/>
               </a:rPr>
-              <a:t>Скелетоны экрана и индикатор сборки AIRuntime</a:t>
+              <a:t>Скелетоны экрана и индикатор сборки страницы</a:t>
             </a:r>
             <a:endParaRPr lang="en-US" sz="1250" dirty="0"/>
           </a:p>
@@ -26935,7 +26935,7 @@
                 <a:ea typeface="Calibri" pitchFamily="34" charset="-122"/>
                 <a:cs typeface="Calibri" pitchFamily="34" charset="-120"/>
               </a:rPr>
-              <a:t>Одним сообщением, как рассказал бы другу. Есть готовые примеры; кнопка активна, когда описание осмысленное.</a:t>
+              <a:t>Одним сообщением, как рассказал бы другу: есть готовые примеры. Сайт и файлы — по желанию, не обязательны.</a:t>
             </a:r>
             <a:endParaRPr lang="en-US" sz="1050" dirty="0"/>
           </a:p>

</xml_diff>

<commit_message>
Point slide 1 at the commit with the reshot screens
The jury checks the materials against the commit named on slide 1, so the hash
has to be the last one before the deadline. It lived in two places; stamp-commit.py
now takes HEAD (or a given sha), writes it into deck.html and the COMMIT constant
in build-pptx.js, and rebuilds both formats - one command as the last step before
submission.

Co-Authored-By: Claude Opus 5 <noreply@anthropic.com>
</commit_message>
<xml_diff>
--- a/docs/max-presentation/presentation.pptx
+++ b/docs/max-presentation/presentation.pptx
@@ -3180,7 +3180,7 @@
                 <a:ea typeface="Consolas" pitchFamily="34" charset="-122"/>
                 <a:cs typeface="Consolas" pitchFamily="34" charset="-120"/>
               </a:rPr>
-              <a:t>376b483180331187bd900c2dce8a18bda4ca5672</a:t>
+              <a:t>eadc752d7bfc2ec65e96972c4c60e3be6547a8ab</a:t>
             </a:r>
             <a:endParaRPr lang="en-US" sz="1150" dirty="0"/>
           </a:p>
@@ -3200,7 +3200,7 @@
                 <a:ea typeface="Calibri" pitchFamily="34" charset="-122"/>
                 <a:cs typeface="Calibri" pitchFamily="34" charset="-120"/>
               </a:rPr>
-              <a:t>ветка main · короткий 376b483</a:t>
+              <a:t>ветка main · короткий eadc752</a:t>
             </a:r>
             <a:endParaRPr lang="en-US" sz="1150" dirty="0"/>
           </a:p>

</xml_diff>

<commit_message>
Drop the track brief from the deck's sources; list only real sources
Co-Authored-By: Claude Opus 5.5 <noreply@anthropic.com>
</commit_message>
<xml_diff>
--- a/docs/max-presentation/presentation.pptx
+++ b/docs/max-presentation/presentation.pptx
@@ -18991,7 +18991,7 @@
         <p:spPr>
           <a:xfrm>
             <a:off x="502920" y="1417320"/>
-            <a:ext cx="5454396" cy="2834640"/>
+            <a:ext cx="11183112" cy="2834640"/>
           </a:xfrm>
           <a:prstGeom prst="roundRect">
             <a:avLst>
@@ -19024,47 +19024,8 @@
         </p:nvSpPr>
         <p:spPr>
           <a:xfrm>
-            <a:off x="740664" y="1600200"/>
-            <a:ext cx="4978908" cy="274320"/>
-          </a:xfrm>
-          <a:prstGeom prst="rect">
-            <a:avLst/>
-          </a:prstGeom>
-          <a:noFill/>
-          <a:ln/>
-        </p:spPr>
-        <p:txBody>
-          <a:bodyPr wrap="square" lIns="0" tIns="0" rIns="0" bIns="0" rtlCol="0" anchor="ctr"/>
-          <a:lstStyle/>
-          <a:p>
-            <a:pPr indent="0" marL="0">
-              <a:buNone/>
-            </a:pPr>
-            <a:r>
-              <a:rPr lang="en-US" sz="1450" b="1" dirty="0">
-                <a:solidFill>
-                  <a:srgbClr val="FFFFFF"/>
-                </a:solidFill>
-                <a:latin typeface="Calibri" pitchFamily="34" charset="0"/>
-                <a:ea typeface="Calibri" pitchFamily="34" charset="-122"/>
-                <a:cs typeface="Calibri" pitchFamily="34" charset="-120"/>
-              </a:rPr>
-              <a:t>Задача и аудитория</a:t>
-            </a:r>
-            <a:endParaRPr lang="en-US" sz="1450" dirty="0"/>
-          </a:p>
-        </p:txBody>
-      </p:sp>
-      <p:sp>
-        <p:nvSpPr>
-          <p:cNvPr id="6" name="Text 4"/>
-          <p:cNvSpPr txBox="1"/>
-          <p:nvPr/>
-        </p:nvSpPr>
-        <p:spPr>
-          <a:xfrm>
-            <a:off x="740664" y="2011680"/>
-            <a:ext cx="4978908" cy="2148840"/>
+            <a:off x="777240" y="1645920"/>
+            <a:ext cx="10634472" cy="2468880"/>
           </a:xfrm>
           <a:prstGeom prst="rect">
             <a:avLst/>
@@ -19081,13 +19042,13 @@
                 <a:spcPct val="108000"/>
               </a:lnSpc>
               <a:spcAft>
-                <a:spcPts val="700"/>
+                <a:spcPts val="900"/>
               </a:spcAft>
               <a:buSzPct val="100000"/>
               <a:buChar char="•"/>
             </a:pPr>
             <a:r>
-              <a:rPr lang="en-US" sz="1200" b="1" dirty="0">
+              <a:rPr lang="en-US" sz="1300" b="1" dirty="0">
                 <a:solidFill>
                   <a:srgbClr val="FFFFFF"/>
                 </a:solidFill>
@@ -19095,10 +19056,10 @@
                 <a:ea typeface="Calibri" pitchFamily="34" charset="-122"/>
                 <a:cs typeface="Calibri" pitchFamily="34" charset="-120"/>
               </a:rPr>
-              <a:t>Задание трека «Эффективный бизнес»</a:t>
-            </a:r>
-            <a:r>
-              <a:rPr lang="en-US" sz="1200" dirty="0">
+              <a:t>ФНС России</a:t>
+            </a:r>
+            <a:r>
+              <a:rPr lang="en-US" sz="1300" dirty="0">
                 <a:solidFill>
                   <a:srgbClr val="A9B7CE"/>
                 </a:solidFill>
@@ -19106,9 +19067,9 @@
                 <a:ea typeface="Calibri" pitchFamily="34" charset="-122"/>
                 <a:cs typeface="Calibri" pitchFamily="34" charset="-120"/>
               </a:rPr>
-              <a:t> — постановка, критерии оценки, рекомендации, формат сдачи</a:t>
-            </a:r>
-            <a:endParaRPr lang="en-US" sz="1200" dirty="0"/>
+              <a:t> — Единый реестр субъектов МСП, июль 2026: 6,6 млн субъектов, 81,8% всех действующих юрлиц и ИП, рост 3,5% год к году</a:t>
+            </a:r>
+            <a:endParaRPr lang="en-US" sz="1300" dirty="0"/>
           </a:p>
           <a:p>
             <a:pPr marL="190500" indent="-190500">
@@ -19116,13 +19077,13 @@
                 <a:spcPct val="108000"/>
               </a:lnSpc>
               <a:spcAft>
-                <a:spcPts val="700"/>
+                <a:spcPts val="900"/>
               </a:spcAft>
               <a:buSzPct val="100000"/>
               <a:buChar char="•"/>
             </a:pPr>
             <a:r>
-              <a:rPr lang="en-US" sz="1200" b="1" dirty="0">
+              <a:rPr lang="en-US" sz="1300" b="1" dirty="0">
                 <a:solidFill>
                   <a:srgbClr val="FFFFFF"/>
                 </a:solidFill>
@@ -19130,10 +19091,10 @@
                 <a:ea typeface="Calibri" pitchFamily="34" charset="-122"/>
                 <a:cs typeface="Calibri" pitchFamily="34" charset="-120"/>
               </a:rPr>
-              <a:t>ФНС России</a:t>
-            </a:r>
-            <a:r>
-              <a:rPr lang="en-US" sz="1200" dirty="0">
+              <a:t>MAX для разработчиков</a:t>
+            </a:r>
+            <a:r>
+              <a:rPr lang="en-US" sz="1300" dirty="0">
                 <a:solidFill>
                   <a:srgbClr val="A9B7CE"/>
                 </a:solidFill>
@@ -19141,118 +19102,23 @@
                 <a:ea typeface="Calibri" pitchFamily="34" charset="-122"/>
                 <a:cs typeface="Calibri" pitchFamily="34" charset="-120"/>
               </a:rPr>
-              <a:t> — Единый реестр субъектов МСП, июль 2026: 6,6 млн субъектов, 81,8% всех действующих юрлиц и ИП, рост 3,5% год к году (приведено по заданию трека)</a:t>
-            </a:r>
-            <a:endParaRPr lang="en-US" sz="1200" dirty="0"/>
-          </a:p>
-        </p:txBody>
-      </p:sp>
-      <p:sp>
-        <p:nvSpPr>
-          <p:cNvPr id="7" name="Shape 5"/>
-          <p:cNvSpPr/>
-          <p:nvPr/>
-        </p:nvSpPr>
-        <p:spPr>
-          <a:xfrm>
-            <a:off x="6231636" y="1417320"/>
-            <a:ext cx="5454396" cy="2834640"/>
-          </a:xfrm>
-          <a:prstGeom prst="roundRect">
-            <a:avLst>
-              <a:gd name="adj" fmla="val 3226"/>
-            </a:avLst>
-          </a:prstGeom>
-          <a:solidFill>
-            <a:srgbClr val="141C2E"/>
-          </a:solidFill>
-          <a:ln w="12700">
-            <a:solidFill>
-              <a:srgbClr val="2A3550"/>
-            </a:solidFill>
-            <a:prstDash val="solid"/>
-          </a:ln>
-          <a:effectLst>
-            <a:outerShdw sx="100000" sy="100000" kx="0" ky="0" algn="bl" rotWithShape="0" blurRad="127000" dist="25400" dir="5400000">
-              <a:srgbClr val="0B1730">
-                <a:alpha val="7000"/>
-              </a:srgbClr>
-            </a:outerShdw>
-          </a:effectLst>
-        </p:spPr>
-      </p:sp>
-      <p:sp>
-        <p:nvSpPr>
-          <p:cNvPr id="8" name="Text 6"/>
-          <p:cNvSpPr txBox="1"/>
-          <p:nvPr/>
-        </p:nvSpPr>
-        <p:spPr>
-          <a:xfrm>
-            <a:off x="6469380" y="1600200"/>
-            <a:ext cx="4978908" cy="274320"/>
-          </a:xfrm>
-          <a:prstGeom prst="rect">
-            <a:avLst/>
-          </a:prstGeom>
-          <a:noFill/>
-          <a:ln/>
-        </p:spPr>
-        <p:txBody>
-          <a:bodyPr wrap="square" lIns="0" tIns="0" rIns="0" bIns="0" rtlCol="0" anchor="ctr"/>
-          <a:lstStyle/>
-          <a:p>
-            <a:pPr indent="0" marL="0">
-              <a:buNone/>
-            </a:pPr>
-            <a:r>
-              <a:rPr lang="en-US" sz="1450" b="1" dirty="0">
-                <a:solidFill>
-                  <a:srgbClr val="FFFFFF"/>
-                </a:solidFill>
-                <a:latin typeface="Calibri" pitchFamily="34" charset="0"/>
-                <a:ea typeface="Calibri" pitchFamily="34" charset="-122"/>
-                <a:cs typeface="Calibri" pitchFamily="34" charset="-120"/>
-              </a:rPr>
-              <a:t>Техническая документация</a:t>
-            </a:r>
-            <a:endParaRPr lang="en-US" sz="1450" dirty="0"/>
-          </a:p>
-        </p:txBody>
-      </p:sp>
-      <p:sp>
-        <p:nvSpPr>
-          <p:cNvPr id="9" name="Text 7"/>
-          <p:cNvSpPr txBox="1"/>
-          <p:nvPr/>
-        </p:nvSpPr>
-        <p:spPr>
-          <a:xfrm>
-            <a:off x="6469380" y="2011680"/>
-            <a:ext cx="4978908" cy="2148840"/>
-          </a:xfrm>
-          <a:prstGeom prst="rect">
-            <a:avLst/>
-          </a:prstGeom>
-          <a:noFill/>
-          <a:ln/>
-        </p:spPr>
-        <p:txBody>
-          <a:bodyPr wrap="square" lIns="0" tIns="0" rIns="0" bIns="0" rtlCol="0" anchor="t"/>
-          <a:lstStyle/>
+              <a:t> — API ботов: методы, вебхуки, кнопки, лимиты запросов</a:t>
+            </a:r>
+            <a:endParaRPr lang="en-US" sz="1300" dirty="0"/>
+          </a:p>
           <a:p>
             <a:pPr marL="190500" indent="-190500">
               <a:lnSpc>
                 <a:spcPct val="108000"/>
               </a:lnSpc>
               <a:spcAft>
-                <a:spcPts val="700"/>
+                <a:spcPts val="900"/>
               </a:spcAft>
               <a:buSzPct val="100000"/>
               <a:buChar char="•"/>
             </a:pPr>
             <a:r>
-              <a:rPr lang="en-US" sz="1200" b="1" dirty="0">
+              <a:rPr lang="en-US" sz="1300" b="1" dirty="0">
                 <a:solidFill>
                   <a:srgbClr val="FFFFFF"/>
                 </a:solidFill>
@@ -19260,10 +19126,10 @@
                 <a:ea typeface="Calibri" pitchFamily="34" charset="-122"/>
                 <a:cs typeface="Calibri" pitchFamily="34" charset="-120"/>
               </a:rPr>
-              <a:t>MAX для разработчиков</a:t>
-            </a:r>
-            <a:r>
-              <a:rPr lang="en-US" sz="1200" dirty="0">
+              <a:t>OpenAPI-спецификация MAX</a:t>
+            </a:r>
+            <a:r>
+              <a:rPr lang="en-US" sz="1300" dirty="0">
                 <a:solidFill>
                   <a:srgbClr val="A9B7CE"/>
                 </a:solidFill>
@@ -19271,9 +19137,9 @@
                 <a:ea typeface="Calibri" pitchFamily="34" charset="-122"/>
                 <a:cs typeface="Calibri" pitchFamily="34" charset="-120"/>
               </a:rPr>
-              <a:t> — API ботов: методы, вебхуки, кнопки, лимиты запросов</a:t>
-            </a:r>
-            <a:endParaRPr lang="en-US" sz="1200" dirty="0"/>
+              <a:t> — github.com/max-messenger/api-schema: форма кнопок и сообщений сверена по ней</a:t>
+            </a:r>
+            <a:endParaRPr lang="en-US" sz="1300" dirty="0"/>
           </a:p>
           <a:p>
             <a:pPr marL="190500" indent="-190500">
@@ -19281,13 +19147,13 @@
                 <a:spcPct val="108000"/>
               </a:lnSpc>
               <a:spcAft>
-                <a:spcPts val="700"/>
+                <a:spcPts val="900"/>
               </a:spcAft>
               <a:buSzPct val="100000"/>
               <a:buChar char="•"/>
             </a:pPr>
             <a:r>
-              <a:rPr lang="en-US" sz="1200" b="1" dirty="0">
+              <a:rPr lang="en-US" sz="1300" b="1" dirty="0">
                 <a:solidFill>
                   <a:srgbClr val="FFFFFF"/>
                 </a:solidFill>
@@ -19295,10 +19161,10 @@
                 <a:ea typeface="Calibri" pitchFamily="34" charset="-122"/>
                 <a:cs typeface="Calibri" pitchFamily="34" charset="-120"/>
               </a:rPr>
-              <a:t>OpenAPI-спецификация MAX</a:t>
-            </a:r>
-            <a:r>
-              <a:rPr lang="en-US" sz="1200" dirty="0">
+              <a:t>MAX Bridge</a:t>
+            </a:r>
+            <a:r>
+              <a:rPr lang="en-US" sz="1300" dirty="0">
                 <a:solidFill>
                   <a:srgbClr val="A9B7CE"/>
                 </a:solidFill>
@@ -19306,9 +19172,31 @@
                 <a:ea typeface="Calibri" pitchFamily="34" charset="-122"/>
                 <a:cs typeface="Calibri" pitchFamily="34" charset="-120"/>
               </a:rPr>
-              <a:t> — github.com/max-messenger/api-schema: форма кнопок и сообщений сверена по ней</a:t>
-            </a:r>
-            <a:endParaRPr lang="en-US" sz="1200" dirty="0"/>
+              <a:t> и </a:t>
+            </a:r>
+            <a:r>
+              <a:rPr lang="en-US" sz="1300" b="1" dirty="0">
+                <a:solidFill>
+                  <a:srgbClr val="FFFFFF"/>
+                </a:solidFill>
+                <a:latin typeface="Calibri" pitchFamily="34" charset="0"/>
+                <a:ea typeface="Calibri" pitchFamily="34" charset="-122"/>
+                <a:cs typeface="Calibri" pitchFamily="34" charset="-120"/>
+              </a:rPr>
+              <a:t>валидация данных</a:t>
+            </a:r>
+            <a:r>
+              <a:rPr lang="en-US" sz="1300" dirty="0">
+                <a:solidFill>
+                  <a:srgbClr val="A9B7CE"/>
+                </a:solidFill>
+                <a:latin typeface="Calibri" pitchFamily="34" charset="0"/>
+                <a:ea typeface="Calibri" pitchFamily="34" charset="-122"/>
+                <a:cs typeface="Calibri" pitchFamily="34" charset="-120"/>
+              </a:rPr>
+              <a:t> — стартовые параметры, контакт, «Поделиться», проверка подписи</a:t>
+            </a:r>
+            <a:endParaRPr lang="en-US" sz="1300" dirty="0"/>
           </a:p>
           <a:p>
             <a:pPr marL="190500" indent="-190500">
@@ -19316,13 +19204,13 @@
                 <a:spcPct val="108000"/>
               </a:lnSpc>
               <a:spcAft>
-                <a:spcPts val="700"/>
+                <a:spcPts val="900"/>
               </a:spcAft>
               <a:buSzPct val="100000"/>
               <a:buChar char="•"/>
             </a:pPr>
             <a:r>
-              <a:rPr lang="en-US" sz="1200" b="1" dirty="0">
+              <a:rPr lang="en-US" sz="1300" b="1" dirty="0">
                 <a:solidFill>
                   <a:srgbClr val="FFFFFF"/>
                 </a:solidFill>
@@ -19330,10 +19218,10 @@
                 <a:ea typeface="Calibri" pitchFamily="34" charset="-122"/>
                 <a:cs typeface="Calibri" pitchFamily="34" charset="-120"/>
               </a:rPr>
-              <a:t>MAX Bridge</a:t>
-            </a:r>
-            <a:r>
-              <a:rPr lang="en-US" sz="1200" dirty="0">
+              <a:t>Минцифры России</a:t>
+            </a:r>
+            <a:r>
+              <a:rPr lang="en-US" sz="1300" dirty="0">
                 <a:solidFill>
                   <a:srgbClr val="A9B7CE"/>
                 </a:solidFill>
@@ -19341,72 +19229,15 @@
                 <a:ea typeface="Calibri" pitchFamily="34" charset="-122"/>
                 <a:cs typeface="Calibri" pitchFamily="34" charset="-120"/>
               </a:rPr>
-              <a:t> и </a:t>
-            </a:r>
-            <a:r>
-              <a:rPr lang="en-US" sz="1200" b="1" dirty="0">
-                <a:solidFill>
-                  <a:srgbClr val="FFFFFF"/>
-                </a:solidFill>
-                <a:latin typeface="Calibri" pitchFamily="34" charset="0"/>
-                <a:ea typeface="Calibri" pitchFamily="34" charset="-122"/>
-                <a:cs typeface="Calibri" pitchFamily="34" charset="-120"/>
-              </a:rPr>
-              <a:t>валидация данных</a:t>
-            </a:r>
-            <a:r>
-              <a:rPr lang="en-US" sz="1200" dirty="0">
-                <a:solidFill>
-                  <a:srgbClr val="A9B7CE"/>
-                </a:solidFill>
-                <a:latin typeface="Calibri" pitchFamily="34" charset="0"/>
-                <a:ea typeface="Calibri" pitchFamily="34" charset="-122"/>
-                <a:cs typeface="Calibri" pitchFamily="34" charset="-120"/>
-              </a:rPr>
-              <a:t> — стартовые параметры, контакт, «Поделиться», проверка подписи</a:t>
-            </a:r>
-            <a:endParaRPr lang="en-US" sz="1200" dirty="0"/>
-          </a:p>
-          <a:p>
-            <a:pPr marL="190500" indent="-190500">
-              <a:lnSpc>
-                <a:spcPct val="108000"/>
-              </a:lnSpc>
-              <a:spcAft>
-                <a:spcPts val="700"/>
-              </a:spcAft>
-              <a:buSzPct val="100000"/>
-              <a:buChar char="•"/>
-            </a:pPr>
-            <a:r>
-              <a:rPr lang="en-US" sz="1200" b="1" dirty="0">
-                <a:solidFill>
-                  <a:srgbClr val="FFFFFF"/>
-                </a:solidFill>
-                <a:latin typeface="Calibri" pitchFamily="34" charset="0"/>
-                <a:ea typeface="Calibri" pitchFamily="34" charset="-122"/>
-                <a:cs typeface="Calibri" pitchFamily="34" charset="-120"/>
-              </a:rPr>
-              <a:t>Минцифры России</a:t>
-            </a:r>
-            <a:r>
-              <a:rPr lang="en-US" sz="1200" dirty="0">
-                <a:solidFill>
-                  <a:srgbClr val="A9B7CE"/>
-                </a:solidFill>
-                <a:latin typeface="Calibri" pitchFamily="34" charset="0"/>
-                <a:ea typeface="Calibri" pitchFamily="34" charset="-122"/>
-                <a:cs typeface="Calibri" pitchFamily="34" charset="-120"/>
-              </a:rPr>
               <a:t> — корневой сертификат для доступа к API платформы</a:t>
             </a:r>
-            <a:endParaRPr lang="en-US" sz="1200" dirty="0"/>
-          </a:p>
-        </p:txBody>
-      </p:sp>
-      <p:sp>
-        <p:nvSpPr>
-          <p:cNvPr id="10" name="Shape 8"/>
+            <a:endParaRPr lang="en-US" sz="1300" dirty="0"/>
+          </a:p>
+        </p:txBody>
+      </p:sp>
+      <p:sp>
+        <p:nvSpPr>
+          <p:cNvPr id="6" name="Shape 4"/>
           <p:cNvSpPr/>
           <p:nvPr/>
         </p:nvSpPr>
@@ -19440,7 +19271,7 @@
       </p:sp>
       <p:sp>
         <p:nvSpPr>
-          <p:cNvPr id="11" name="Text 9"/>
+          <p:cNvPr id="7" name="Text 5"/>
           <p:cNvSpPr txBox="1"/>
           <p:nvPr/>
         </p:nvSpPr>
@@ -19482,7 +19313,7 @@
       </p:sp>
       <p:sp>
         <p:nvSpPr>
-          <p:cNvPr id="12" name="Text 10"/>
+          <p:cNvPr id="8" name="Text 6"/>
           <p:cNvSpPr txBox="1"/>
           <p:nvPr/>
         </p:nvSpPr>
@@ -19543,7 +19374,7 @@
       </p:sp>
       <p:sp>
         <p:nvSpPr>
-          <p:cNvPr id="13" name="Text 11"/>
+          <p:cNvPr id="9" name="Text 7"/>
           <p:cNvSpPr txBox="1"/>
           <p:nvPr/>
         </p:nvSpPr>

</xml_diff>

<commit_message>
Point the MAX deck at the airuntime-max repository
Co-Authored-By: Claude Opus 5.5 <noreply@anthropic.com>
</commit_message>
<xml_diff>
--- a/docs/max-presentation/presentation.pptx
+++ b/docs/max-presentation/presentation.pptx
@@ -3188,7 +3188,7 @@
                 <a:ea typeface="Consolas" pitchFamily="34" charset="-122"/>
                 <a:cs typeface="Consolas" pitchFamily="34" charset="-120"/>
               </a:rPr>
-              <a:t>github.com/airuntime-ru/airuntime</a:t>
+              <a:t>github.com/airuntime-ru/airuntime-max</a:t>
             </a:r>
             <a:endParaRPr lang="en-US" sz="1150" dirty="0"/>
           </a:p>
@@ -19986,7 +19986,7 @@
                 <a:ea typeface="Calibri" pitchFamily="34" charset="-122"/>
                 <a:cs typeface="Calibri" pitchFamily="34" charset="-120"/>
               </a:rPr>
-              <a:t>github.com/airuntime-ru/airuntime</a:t>
+              <a:t>github.com/airuntime-ru/airuntime-max</a:t>
             </a:r>
             <a:endParaRPr lang="en-US" sz="1300" dirty="0"/>
           </a:p>

</xml_diff>